<commit_message>
Presentation speacker text changes.
</commit_message>
<xml_diff>
--- a/reports/presentation/wildfire_exposure_screening_capstone_final.pptx
+++ b/reports/presentation/wildfire_exposure_screening_capstone_final.pptx
@@ -973,7 +973,11 @@
           <a:p>
             <a:r>
               <a:rPr lang="en-US" b="1" dirty="0"/>
-              <a:t>What to say:</a:t>
+              <a:t>What to </a:t>
+            </a:r>
+            <a:r>
+              <a:rPr lang="en-US" b="1" dirty="0" err="1"/>
+              <a:t>say:s</a:t>
             </a:r>
             <a:endParaRPr lang="en-US" dirty="0"/>
           </a:p>
@@ -1083,7 +1087,31 @@
             </a:r>
             <a:r>
               <a:rPr b="1" dirty="0"/>
-              <a:t>2022→2023, 2023→2024 and 2024→2025</a:t>
+              <a:t>2022</a:t>
+            </a:r>
+            <a:r>
+              <a:rPr lang="en-US" b="1" dirty="0"/>
+              <a:t>-&gt;</a:t>
+            </a:r>
+            <a:r>
+              <a:rPr b="1" dirty="0"/>
+              <a:t>2023, 2023</a:t>
+            </a:r>
+            <a:r>
+              <a:rPr lang="en-US" b="1" dirty="0"/>
+              <a:t>-&gt;</a:t>
+            </a:r>
+            <a:r>
+              <a:rPr b="1" dirty="0"/>
+              <a:t>2024 and 2024</a:t>
+            </a:r>
+            <a:r>
+              <a:rPr lang="en-US" b="1" dirty="0"/>
+              <a:t>-&gt;</a:t>
+            </a:r>
+            <a:r>
+              <a:rPr b="1" dirty="0"/>
+              <a:t>2025</a:t>
             </a:r>
             <a:r>
               <a:rPr dirty="0"/>
@@ -1127,7 +1155,15 @@
             </a:r>
             <a:r>
               <a:rPr b="1" dirty="0"/>
-              <a:t>2035→2036</a:t>
+              <a:t>2035</a:t>
+            </a:r>
+            <a:r>
+              <a:rPr lang="en-US" b="1" dirty="0"/>
+              <a:t>-&gt;</a:t>
+            </a:r>
+            <a:r>
+              <a:rPr b="1" dirty="0"/>
+              <a:t>2036</a:t>
             </a:r>
             <a:r>
               <a:rPr dirty="0"/>

</xml_diff>

<commit_message>
Promote Model V2 and align final-test reporting.
</commit_message>
<xml_diff>
--- a/reports/presentation/wildfire_exposure_screening_capstone_final.pptx
+++ b/reports/presentation/wildfire_exposure_screening_capstone_final.pptx
@@ -968,7 +968,7 @@
             </a:r>
           </a:p>
           <a:p>
-            <a:endParaRPr lang="en-US" dirty="0"/>
+            <a:endParaRPr lang="en-US" b="1" dirty="0"/>
           </a:p>
           <a:p>
             <a:r>
@@ -7311,7 +7311,7 @@
           <a:bodyPr/>
           <a:lstStyle/>
           <a:p>
-            <a:endParaRPr/>
+            <a:endParaRPr dirty="0"/>
           </a:p>
         </p:txBody>
       </p:sp>
@@ -7742,52 +7742,82 @@
         <p:spPr>
           <a:xfrm>
             <a:off x="713232" y="2578608"/>
-            <a:ext cx="3611880" cy="347472"/>
-          </a:xfrm>
-          <a:prstGeom prst="rect">
-            <a:avLst/>
-          </a:prstGeom>
-          <a:noFill/>
-        </p:spPr>
-        <p:txBody>
-          <a:bodyPr wrap="square" lIns="0" tIns="0" rIns="0" bIns="0" anchor="ctr"/>
-          <a:lstStyle/>
+            <a:ext cx="3611880" cy="466344"/>
+          </a:xfrm>
+          <a:prstGeom prst="rect">
+            <a:avLst/>
+          </a:prstGeom>
+          <a:noFill/>
+        </p:spPr>
+        <p:txBody>
+          <a:bodyPr wrap="square" lIns="0" tIns="0" rIns="0" bIns="0" anchor="ctr"/>
+          <a:lstStyle/>
+          <a:p>
+            <a:r>
+              <a:rPr sz="850" dirty="0">
+                <a:solidFill>
+                  <a:srgbClr val="1A2638"/>
+                </a:solidFill>
+              </a:rPr>
+              <a:t>Nine-feature </a:t>
+            </a:r>
+            <a:r>
+              <a:rPr lang="en-US" sz="850" dirty="0">
+                <a:solidFill>
+                  <a:srgbClr val="1A2638"/>
+                </a:solidFill>
+              </a:rPr>
+              <a:t>two-stage regression</a:t>
+            </a:r>
+            <a:r>
+              <a:rPr sz="850" dirty="0">
+                <a:solidFill>
+                  <a:srgbClr val="1A2638"/>
+                </a:solidFill>
+              </a:rPr>
+              <a:t> model</a:t>
+            </a:r>
+            <a:r>
+              <a:rPr lang="en-US" sz="850" dirty="0">
+                <a:solidFill>
+                  <a:srgbClr val="1A2638"/>
+                </a:solidFill>
+              </a:rPr>
+              <a:t>:</a:t>
+            </a:r>
+          </a:p>
+          <a:p>
+            <a:pPr marL="171450" indent="-171450">
+              <a:buFont typeface="Arial" panose="020B0604020202020204" pitchFamily="34" charset="0"/>
+              <a:buChar char="•"/>
+            </a:pPr>
+            <a:r>
+              <a:rPr lang="en-US" sz="800" b="1" dirty="0" err="1"/>
+              <a:t>HistGradientBoostingClassifier</a:t>
+            </a:r>
+            <a:r>
+              <a:rPr lang="en-US" sz="800" dirty="0"/>
+              <a:t> for occurrence</a:t>
+            </a:r>
+          </a:p>
+          <a:p>
+            <a:pPr marL="171450" indent="-171450">
+              <a:buFont typeface="Arial" panose="020B0604020202020204" pitchFamily="34" charset="0"/>
+              <a:buChar char="•"/>
+            </a:pPr>
+            <a:r>
+              <a:rPr lang="en-US" sz="800" b="1" dirty="0" err="1"/>
+              <a:t>HistGradientBoostingRegressor</a:t>
+            </a:r>
+            <a:r>
+              <a:rPr lang="en-US" sz="800" dirty="0"/>
+              <a:t> for positive burned share</a:t>
+            </a:r>
+          </a:p>
           <a:p>
             <a:pPr marL="0" indent="0">
               <a:buNone/>
             </a:pPr>
-            <a:r>
-              <a:rPr sz="850" dirty="0">
-                <a:solidFill>
-                  <a:srgbClr val="1A2638"/>
-                </a:solidFill>
-              </a:rPr>
-              <a:t>Nine-feature </a:t>
-            </a:r>
-            <a:r>
-              <a:rPr lang="en-US" sz="850" dirty="0">
-                <a:solidFill>
-                  <a:srgbClr val="1A2638"/>
-                </a:solidFill>
-              </a:rPr>
-              <a:t>two-stage regression</a:t>
-            </a:r>
-            <a:r>
-              <a:rPr sz="850" dirty="0">
-                <a:solidFill>
-                  <a:srgbClr val="1A2638"/>
-                </a:solidFill>
-              </a:rPr>
-              <a:t> model - </a:t>
-            </a:r>
-            <a:r>
-              <a:rPr sz="850" b="1" dirty="0" err="1">
-                <a:solidFill>
-                  <a:srgbClr val="1A2638"/>
-                </a:solidFill>
-              </a:rPr>
-              <a:t>HistGradientBoosting</a:t>
-            </a:r>
             <a:endParaRPr sz="850" b="1" dirty="0"/>
           </a:p>
         </p:txBody>

</xml_diff>

<commit_message>
Updated map image added to pptx.
</commit_message>
<xml_diff>
--- a/reports/presentation/wildfire_exposure_screening_capstone_final.pptx
+++ b/reports/presentation/wildfire_exposure_screening_capstone_final.pptx
@@ -4805,22 +4805,34 @@
       </p:sp>
       <p:pic>
         <p:nvPicPr>
-          <p:cNvPr id="69" name="Picture 36"/>
+          <p:cNvPr id="9" name="Picture 8">
+            <a:extLst>
+              <a:ext uri="{FF2B5EF4-FFF2-40B4-BE49-F238E27FC236}">
+                <a16:creationId xmlns:a16="http://schemas.microsoft.com/office/drawing/2014/main" id="{8DB38B7C-228F-B2AA-92AC-419C3B16224E}"/>
+              </a:ext>
+            </a:extLst>
+          </p:cNvPr>
           <p:cNvPicPr>
             <a:picLocks noChangeAspect="1"/>
           </p:cNvPicPr>
           <p:nvPr/>
         </p:nvPicPr>
         <p:blipFill>
-          <a:blip r:embed="rId3"/>
+          <a:blip r:embed="rId3">
+            <a:extLst>
+              <a:ext uri="{28A0092B-C50C-407E-A947-70E740481C1C}">
+                <a14:useLocalDpi xmlns:a14="http://schemas.microsoft.com/office/drawing/2010/main" val="0"/>
+              </a:ext>
+            </a:extLst>
+          </a:blip>
           <a:stretch>
             <a:fillRect/>
           </a:stretch>
         </p:blipFill>
         <p:spPr>
           <a:xfrm>
-            <a:off x="774375" y="1111192"/>
-            <a:ext cx="7595250" cy="3765417"/>
+            <a:off x="742950" y="1107383"/>
+            <a:ext cx="7581900" cy="3810525"/>
           </a:xfrm>
           <a:prstGeom prst="rect">
             <a:avLst/>

</xml_diff>

<commit_message>
Key Findings 3 slide corrections after model improvements.
</commit_message>
<xml_diff>
--- a/reports/presentation/wildfire_exposure_screening_capstone_final.pptx
+++ b/reports/presentation/wildfire_exposure_screening_capstone_final.pptx
@@ -964,7 +964,7 @@
             </a:r>
             <a:r>
               <a:rPr lang="en-US" dirty="0"/>
-              <a:t> The nine-feature two-stage regression modestly improves useful comparative diagnostics over historical recurrence alone, while extreme events remain difficult.</a:t>
+              <a:t> The nine-feature two-stage regression improves average comparative error and burned-share ranking over historical recurrence alone, while extreme fire outcomes remain difficult.</a:t>
             </a:r>
           </a:p>
           <a:p>
@@ -973,30 +973,58 @@
           <a:p>
             <a:r>
               <a:rPr lang="en-US" b="1" dirty="0"/>
-              <a:t>What to </a:t>
-            </a:r>
-            <a:r>
-              <a:rPr lang="en-US" b="1" dirty="0" err="1"/>
-              <a:t>say:s</a:t>
-            </a:r>
-            <a:endParaRPr lang="en-US" dirty="0"/>
-          </a:p>
-          <a:p>
-            <a:r>
+              <a:t>What to say:</a:t>
+            </a:r>
+            <a:br>
               <a:rPr lang="en-US" dirty="0"/>
-              <a:t>“This slide compares two approaches using the held-out final period: predictor years 2022–2024 and observed outcomes 2023–2025.</a:t>
-            </a:r>
-          </a:p>
-          <a:p>
+            </a:br>
             <a:r>
               <a:rPr lang="en-US" dirty="0"/>
-              <a:t>The historical-recurrence baseline is a transparent project benchmark. It groups training records by the number of previously burned years in the 2 km context and uses the training-period average next-year burned share for each group. It is not a library model.</a:t>
-            </a:r>
-          </a:p>
-          <a:p>
+              <a:t>“This slide compares two approaches using the held-out final period: predictor </a:t>
+            </a:r>
+            <a:r>
+              <a:rPr lang="en-US"/>
+              <a:t>years </a:t>
+            </a:r>
+            <a:r>
+              <a:rPr lang="en-US" b="1"/>
+              <a:t>2022 - 2024</a:t>
+            </a:r>
+            <a:r>
+              <a:rPr lang="en-US"/>
+              <a:t> </a:t>
+            </a:r>
             <a:r>
               <a:rPr lang="en-US" dirty="0"/>
-              <a:t>The nine-feature two-stage regression uses </a:t>
+              <a:t>and observed outcomes </a:t>
+            </a:r>
+            <a:r>
+              <a:rPr lang="en-US" b="1" dirty="0"/>
+              <a:t>2023</a:t>
+            </a:r>
+            <a:r>
+              <a:rPr lang="ru-RU" b="1" dirty="0"/>
+              <a:t> - </a:t>
+            </a:r>
+            <a:r>
+              <a:rPr lang="en-US" b="1" dirty="0"/>
+              <a:t>2025</a:t>
+            </a:r>
+            <a:r>
+              <a:rPr lang="en-US" dirty="0"/>
+              <a:t>.</a:t>
+            </a:r>
+          </a:p>
+          <a:p>
+            <a:r>
+              <a:rPr lang="en-US" dirty="0"/>
+              <a:t>The historical-recurrence baseline is a transparent project benchmark. It groups training records by the number of previously burned years in the 2 km context and uses the training-period average next-year burned share for each group. It is an empirical project benchmark, not a library model.</a:t>
+            </a:r>
+          </a:p>
+          <a:p>
+            <a:r>
+              <a:rPr lang="en-US" dirty="0"/>
+              <a:t>The nine-feature Model V2 uses two </a:t>
             </a:r>
             <a:r>
               <a:rPr lang="en-US" dirty="0" err="1"/>
@@ -1004,13 +1032,29 @@
             </a:r>
             <a:r>
               <a:rPr lang="en-US" dirty="0"/>
-              <a:t>. First, it estimates whether burning is expected in a cell. Second, when burning is expected, it estimates how much of the cell’s land area may burn. The two parts are combined into one continuous estimated burned share.</a:t>
+              <a:t> components. The first estimates whether burning is likely in a cell. The second estimates how much of the cell’s land area may burn when burning occurs. These two parts are combined into one continuous estimated burned share.</a:t>
             </a:r>
           </a:p>
           <a:p>
             <a:r>
               <a:rPr lang="en-US" dirty="0"/>
-              <a:t>The model lowers MAE from 0.029 to 0.021 and improves Capture@20% from 0.482 to 0.500. RMSE remains approximately the same, at 0.111, which tells us that larger and more extreme fire outcomes are still difficult to estimate accurately.</a:t>
+              <a:t>On the final test, Model V2 lowers MAE from </a:t>
+            </a:r>
+            <a:r>
+              <a:rPr lang="en-US" b="1" dirty="0"/>
+              <a:t>0.0292 to 0.0209</a:t>
+            </a:r>
+            <a:r>
+              <a:rPr lang="en-US" dirty="0"/>
+              <a:t>. RMSE is almost unchanged but slightly higher, from </a:t>
+            </a:r>
+            <a:r>
+              <a:rPr lang="en-US" b="1" dirty="0"/>
+              <a:t>0.1106 to 0.1110</a:t>
+            </a:r>
+            <a:r>
+              <a:rPr lang="en-US" dirty="0"/>
+              <a:t>, showing that larger and more extreme fire outcomes remain difficult.”</a:t>
             </a:r>
           </a:p>
           <a:p>
@@ -1018,8 +1062,86 @@
           </a:p>
           <a:p>
             <a:r>
+              <a:rPr lang="en-US" b="1" dirty="0"/>
+              <a:t>Capture@20% is a validation test of the ranking.</a:t>
+            </a:r>
+            <a:r>
               <a:rPr lang="en-US" dirty="0"/>
-              <a:t>Capture@20% is not a buyer threshold. For example, using 2024 data, the model ranks cells for expected 2025 burned share. We then check how much of the actual 2025 burned area occurred within the 20% highest-ranked cells. It measures ranking usefulness, not the proportion of land that burned.”</a:t>
+              <a:t> For each predictor year, the model ranks cells using information from year </a:t>
+            </a:r>
+            <a:r>
+              <a:rPr lang="en-US" b="1" dirty="0"/>
+              <a:t>T</a:t>
+            </a:r>
+            <a:r>
+              <a:rPr lang="en-US" dirty="0"/>
+              <a:t> and estimates burned share for </a:t>
+            </a:r>
+            <a:r>
+              <a:rPr lang="en-US" b="1" dirty="0"/>
+              <a:t>T+1</a:t>
+            </a:r>
+            <a:r>
+              <a:rPr lang="en-US" dirty="0"/>
+              <a:t>. For example, for </a:t>
+            </a:r>
+            <a:r>
+              <a:rPr lang="en-US" b="1" dirty="0"/>
+              <a:t>2024 -&gt; 2025</a:t>
+            </a:r>
+            <a:r>
+              <a:rPr lang="en-US" dirty="0"/>
+              <a:t>, it ranks cells using 2024 predictor data and is later checked against observed ICNF burned areas from 2025.</a:t>
+            </a:r>
+          </a:p>
+          <a:p>
+            <a:r>
+              <a:rPr lang="en-US" dirty="0"/>
+              <a:t>The final evaluation covers </a:t>
+            </a:r>
+            <a:r>
+              <a:rPr lang="en-US" b="1" dirty="0"/>
+              <a:t>2022 -&gt; 2023, 2023 -&gt; 2024, and 2024 -&gt; 2025</a:t>
+            </a:r>
+            <a:r>
+              <a:rPr lang="en-US" dirty="0"/>
+              <a:t>. We select the highest-scored 20% of cells and measure how much of the total observed burned-share mass occurred within those cells.</a:t>
+            </a:r>
+          </a:p>
+          <a:p>
+            <a:r>
+              <a:rPr lang="en-US" dirty="0"/>
+              <a:t>Across the final test, the historical baseline captured </a:t>
+            </a:r>
+            <a:r>
+              <a:rPr lang="en-US" b="1" dirty="0"/>
+              <a:t>40.2%</a:t>
+            </a:r>
+            <a:r>
+              <a:rPr lang="en-US" dirty="0"/>
+              <a:t> of observed burned-share mass in its top-ranked 20% of cells. Model V2 captured </a:t>
+            </a:r>
+            <a:r>
+              <a:rPr lang="en-US" b="1" dirty="0"/>
+              <a:t>57.2%</a:t>
+            </a:r>
+            <a:r>
+              <a:rPr lang="en-US" dirty="0"/>
+              <a:t>.</a:t>
+            </a:r>
+          </a:p>
+          <a:p>
+            <a:r>
+              <a:rPr lang="en-US" dirty="0"/>
+              <a:t>This does not mean that 20% of the land burned. It is a retrospective ranking diagnostic, not a buyer threshold or a property-level forecast. The same logic could later be applied to </a:t>
+            </a:r>
+            <a:r>
+              <a:rPr lang="en-US" b="1" dirty="0"/>
+              <a:t>2035 -&gt; 2036</a:t>
+            </a:r>
+            <a:r>
+              <a:rPr lang="en-US" dirty="0"/>
+              <a:t>, but only after the 2036 outcome data become available.”</a:t>
             </a:r>
           </a:p>
           <a:p>
@@ -1032,158 +1154,37 @@
             </a:r>
             <a:r>
               <a:rPr lang="en-US" dirty="0"/>
-              <a:t> “So the practical question becomes: how should someone use this evidence responsibly?”</a:t>
-            </a:r>
-          </a:p>
-          <a:p>
+              <a:t> “The practical question is whether the model provides a useful ranking for broad-area screening.”</a:t>
+            </a:r>
+          </a:p>
+          <a:p>
+            <a:endParaRPr lang="en-US" b="1" dirty="0"/>
+          </a:p>
+          <a:p>
+            <a:r>
+              <a:rPr lang="en-US" b="1" dirty="0"/>
+              <a:t>[Sources]</a:t>
+            </a:r>
             <a:br>
-              <a:rPr lang="en-US" b="1" dirty="0"/>
+              <a:rPr lang="en-US" dirty="0"/>
             </a:br>
             <a:r>
-              <a:rPr b="1" dirty="0"/>
-              <a:t>Capture@20% is a validation test of the ranking.</a:t>
-            </a:r>
-            <a:r>
-              <a:rPr dirty="0"/>
-              <a:t> For each predictor year, the model ranks cells using data from year </a:t>
-            </a:r>
-            <a:r>
-              <a:rPr b="1" dirty="0"/>
-              <a:t>T</a:t>
-            </a:r>
-            <a:r>
-              <a:rPr dirty="0"/>
-              <a:t> and estimates burned share for </a:t>
-            </a:r>
-            <a:r>
-              <a:rPr b="1" dirty="0"/>
-              <a:t>T+1</a:t>
-            </a:r>
-            <a:r>
-              <a:rPr dirty="0"/>
-              <a:t>. For example, for </a:t>
-            </a:r>
-            <a:r>
-              <a:rPr b="1" dirty="0"/>
-              <a:t>T = 2024</a:t>
-            </a:r>
-            <a:r>
-              <a:rPr dirty="0"/>
-              <a:t>, it ranks cells using 2024 predictor data and is later checked against the actual ICNF burned areas observed in </a:t>
-            </a:r>
-            <a:r>
-              <a:rPr b="1" dirty="0"/>
-              <a:t>2025</a:t>
-            </a:r>
-            <a:r>
-              <a:rPr dirty="0"/>
-              <a:t>.</a:t>
-            </a:r>
-          </a:p>
-          <a:p>
-            <a:r>
-              <a:rPr dirty="0"/>
-              <a:t>The final evaluation covers the year pairs </a:t>
-            </a:r>
-            <a:r>
-              <a:rPr b="1" dirty="0"/>
-              <a:t>2022</a:t>
-            </a:r>
-            <a:r>
-              <a:rPr lang="en-US" b="1" dirty="0"/>
-              <a:t>-&gt;</a:t>
-            </a:r>
-            <a:r>
-              <a:rPr b="1" dirty="0"/>
-              <a:t>2023, 2023</a:t>
-            </a:r>
-            <a:r>
-              <a:rPr lang="en-US" b="1" dirty="0"/>
-              <a:t>-&gt;</a:t>
-            </a:r>
-            <a:r>
-              <a:rPr b="1" dirty="0"/>
-              <a:t>2024 and 2024</a:t>
-            </a:r>
-            <a:r>
-              <a:rPr lang="en-US" b="1" dirty="0"/>
-              <a:t>-&gt;</a:t>
-            </a:r>
-            <a:r>
-              <a:rPr b="1" dirty="0"/>
-              <a:t>2025</a:t>
-            </a:r>
-            <a:r>
-              <a:rPr dirty="0"/>
-              <a:t>. For each pair, we select the highest-scored 20% of cells and measure how much of the burned share observed in </a:t>
-            </a:r>
-            <a:r>
-              <a:rPr b="1" dirty="0"/>
-              <a:t>T+1</a:t>
-            </a:r>
-            <a:r>
-              <a:rPr dirty="0"/>
-              <a:t> occurred in those cells.</a:t>
-            </a:r>
-          </a:p>
-          <a:p>
-            <a:r>
-              <a:rPr dirty="0"/>
-              <a:t>Across the final test, the historical baseline captured </a:t>
-            </a:r>
-            <a:r>
-              <a:rPr b="1" dirty="0"/>
-              <a:t>48.2%</a:t>
-            </a:r>
-            <a:r>
-              <a:rPr dirty="0"/>
-              <a:t> of observed burned share in its top-ranked 20% of cells. The nine-feature model captured </a:t>
-            </a:r>
-            <a:r>
-              <a:rPr b="1" dirty="0"/>
-              <a:t>50.0%</a:t>
-            </a:r>
-            <a:r>
-              <a:rPr dirty="0"/>
-              <a:t>.</a:t>
-            </a:r>
-          </a:p>
-          <a:p>
-            <a:r>
-              <a:rPr dirty="0"/>
-              <a:t>This does not mean that 20% of the land burned. It is only a retrospective ranking diagnostic. In a future cycle, the same logic would apply to </a:t>
-            </a:r>
-            <a:r>
-              <a:rPr b="1" dirty="0"/>
-              <a:t>2035</a:t>
-            </a:r>
-            <a:r>
-              <a:rPr lang="en-US" b="1" dirty="0"/>
-              <a:t>-&gt;</a:t>
-            </a:r>
-            <a:r>
-              <a:rPr b="1" dirty="0"/>
-              <a:t>2036</a:t>
-            </a:r>
-            <a:r>
-              <a:rPr dirty="0"/>
-              <a:t>, but only after the 2036 outcome data became available.</a:t>
-            </a:r>
-          </a:p>
-          <a:p>
-            <a:endParaRPr dirty="0"/>
-          </a:p>
-          <a:p>
-            <a:r>
-              <a:rPr dirty="0"/>
-              <a:t>[Sources]</a:t>
+              <a:rPr lang="en-US" dirty="0"/>
+              <a:t>reports/validation/model_final_decision.md</a:t>
             </a:r>
             <a:br>
-              <a:rPr dirty="0"/>
+              <a:rPr lang="en-US" dirty="0"/>
             </a:br>
             <a:r>
-              <a:rPr dirty="0"/>
-              <a:t>reports/validation/model_final_decision.md; reports/figures/model_final_test_metric_comparison.png</a:t>
+              <a:rPr lang="en-US" dirty="0"/>
+              <a:t>reports/validation/final_temporal_test_2022_2024.md</a:t>
+            </a:r>
+            <a:br>
+              <a:rPr lang="en-US" dirty="0"/>
+            </a:br>
+            <a:r>
+              <a:rPr lang="en-US" dirty="0"/>
+              <a:t>reports/figures/model_final_test_metric_comparison.png</a:t>
             </a:r>
           </a:p>
         </p:txBody>
@@ -3497,14 +3498,14 @@
               <a:buNone/>
             </a:pPr>
             <a:r>
-              <a:rPr sz="2000" b="1">
+              <a:rPr lang="en-US" sz="2000" b="1" dirty="0">
                 <a:solidFill>
                   <a:srgbClr val="E8A020"/>
                 </a:solidFill>
               </a:rPr>
-              <a:t>→</a:t>
-            </a:r>
-            <a:endParaRPr sz="2000"/>
+              <a:t>-&gt;</a:t>
+            </a:r>
+            <a:endParaRPr sz="2000" dirty="0"/>
           </a:p>
         </p:txBody>
       </p:sp>
@@ -3904,14 +3905,14 @@
               <a:buNone/>
             </a:pPr>
             <a:r>
-              <a:rPr sz="2000" b="1">
+              <a:rPr lang="en-US" sz="2000" b="1" dirty="0">
                 <a:solidFill>
                   <a:srgbClr val="E8A020"/>
                 </a:solidFill>
               </a:rPr>
-              <a:t>→</a:t>
-            </a:r>
-            <a:endParaRPr sz="2000"/>
+              <a:t>-&gt;</a:t>
+            </a:r>
+            <a:endParaRPr sz="2000" dirty="0"/>
           </a:p>
         </p:txBody>
       </p:sp>
@@ -7495,30 +7496,46 @@
         </p:nvSpPr>
         <p:spPr>
           <a:xfrm>
-            <a:off x="713232" y="1773936"/>
-            <a:ext cx="3611880" cy="347472"/>
-          </a:xfrm>
-          <a:prstGeom prst="rect">
-            <a:avLst/>
-          </a:prstGeom>
-          <a:noFill/>
-        </p:spPr>
-        <p:txBody>
-          <a:bodyPr wrap="square" lIns="0" tIns="0" rIns="0" bIns="0" anchor="ctr"/>
-          <a:lstStyle/>
-          <a:p>
-            <a:pPr marL="0" indent="0">
-              <a:buNone/>
-            </a:pPr>
-            <a:r>
-              <a:rPr sz="850">
+            <a:off x="713232" y="1801368"/>
+            <a:ext cx="3611880" cy="246888"/>
+          </a:xfrm>
+          <a:prstGeom prst="rect">
+            <a:avLst/>
+          </a:prstGeom>
+          <a:noFill/>
+        </p:spPr>
+        <p:txBody>
+          <a:bodyPr wrap="square" lIns="0" tIns="0" rIns="0" bIns="0" anchor="ctr"/>
+          <a:lstStyle/>
+          <a:p>
+            <a:r>
+              <a:rPr lang="en-US" sz="800" dirty="0"/>
+              <a:t>Historical </a:t>
+            </a:r>
+            <a:r>
+              <a:rPr lang="en-US" sz="800" b="1" dirty="0"/>
+              <a:t>recurrence</a:t>
+            </a:r>
+            <a:r>
+              <a:rPr lang="en-US" sz="800" dirty="0"/>
+              <a:t> benchmark </a:t>
+            </a:r>
+            <a:r>
+              <a:rPr sz="850" dirty="0">
                 <a:solidFill>
                   <a:srgbClr val="1A2638"/>
                 </a:solidFill>
               </a:rPr>
-              <a:t>Baseline -&gt; nine-feature model</a:t>
-            </a:r>
-            <a:endParaRPr sz="850"/>
+              <a:t> -&gt; </a:t>
+            </a:r>
+            <a:r>
+              <a:rPr lang="en-US" sz="800" b="1" dirty="0"/>
+              <a:t>Nine-feature</a:t>
+            </a:r>
+            <a:r>
+              <a:rPr lang="en-US" sz="800" dirty="0"/>
+              <a:t> Model</a:t>
+            </a:r>
           </a:p>
         </p:txBody>
       </p:sp>
@@ -7630,34 +7647,31 @@
               <a:buNone/>
             </a:pPr>
             <a:r>
-              <a:rPr sz="850">
+              <a:rPr sz="850" dirty="0">
                 <a:solidFill>
                   <a:srgbClr val="1A2638"/>
                 </a:solidFill>
               </a:rPr>
-              <a:t>Historical recurrence baseline </a:t>
-            </a:r>
-            <a:r>
-              <a:rPr sz="800" b="1">
-                <a:solidFill>
-                  <a:srgbClr val="1A2638"/>
-                </a:solidFill>
-              </a:rPr>
-              <a:t>- </a:t>
-            </a:r>
-            <a:r>
-              <a:rPr sz="800" b="1"/>
-              <a:t>groups training records by the number of previously burned years </a:t>
-            </a:r>
-            <a:r>
-              <a:rPr sz="800" b="1">
-                <a:solidFill>
-                  <a:srgbClr val="1A2638"/>
-                </a:solidFill>
-              </a:rPr>
-              <a:t> </a:t>
-            </a:r>
-            <a:endParaRPr sz="800" b="1"/>
+              <a:t>Historical recurrence baseline</a:t>
+            </a:r>
+            <a:endParaRPr lang="en-US" sz="850" dirty="0">
+              <a:solidFill>
+                <a:srgbClr val="1A2638"/>
+              </a:solidFill>
+            </a:endParaRPr>
+          </a:p>
+          <a:p>
+            <a:r>
+              <a:rPr lang="en-US" sz="700" i="1" dirty="0">
+                <a:solidFill>
+                  <a:schemeClr val="tx1">
+                    <a:lumMod val="50000"/>
+                    <a:lumOff val="50000"/>
+                  </a:schemeClr>
+                </a:solidFill>
+              </a:rPr>
+              <a:t>a simple reference based only on previous burned-year counts</a:t>
+            </a:r>
           </a:p>
         </p:txBody>
       </p:sp>
@@ -7754,7 +7768,7 @@
         <p:spPr>
           <a:xfrm>
             <a:off x="713232" y="2578608"/>
-            <a:ext cx="3611880" cy="466344"/>
+            <a:ext cx="3611880" cy="548640"/>
           </a:xfrm>
           <a:prstGeom prst="rect">
             <a:avLst/>
@@ -7804,11 +7818,25 @@
               <a:buChar char="•"/>
             </a:pPr>
             <a:r>
-              <a:rPr lang="en-US" sz="800" b="1" dirty="0" err="1"/>
+              <a:rPr lang="en-US" sz="700" b="1" i="1" dirty="0" err="1">
+                <a:solidFill>
+                  <a:schemeClr val="tx1">
+                    <a:lumMod val="50000"/>
+                    <a:lumOff val="50000"/>
+                  </a:schemeClr>
+                </a:solidFill>
+              </a:rPr>
               <a:t>HistGradientBoostingClassifier</a:t>
             </a:r>
             <a:r>
-              <a:rPr lang="en-US" sz="800" dirty="0"/>
+              <a:rPr lang="en-US" sz="700" i="1" dirty="0">
+                <a:solidFill>
+                  <a:schemeClr val="tx1">
+                    <a:lumMod val="50000"/>
+                    <a:lumOff val="50000"/>
+                  </a:schemeClr>
+                </a:solidFill>
+              </a:rPr>
               <a:t> for occurrence</a:t>
             </a:r>
           </a:p>
@@ -7818,13 +7846,41 @@
               <a:buChar char="•"/>
             </a:pPr>
             <a:r>
-              <a:rPr lang="en-US" sz="800" b="1" dirty="0" err="1"/>
+              <a:rPr lang="en-US" sz="700" b="1" i="1" dirty="0" err="1">
+                <a:solidFill>
+                  <a:schemeClr val="tx1">
+                    <a:lumMod val="50000"/>
+                    <a:lumOff val="50000"/>
+                  </a:schemeClr>
+                </a:solidFill>
+              </a:rPr>
               <a:t>HistGradientBoostingRegressor</a:t>
             </a:r>
             <a:r>
-              <a:rPr lang="en-US" sz="800" dirty="0"/>
+              <a:rPr lang="en-US" sz="700" i="1" dirty="0">
+                <a:solidFill>
+                  <a:schemeClr val="tx1">
+                    <a:lumMod val="50000"/>
+                    <a:lumOff val="50000"/>
+                  </a:schemeClr>
+                </a:solidFill>
+              </a:rPr>
               <a:t> for positive burned share</a:t>
             </a:r>
+          </a:p>
+          <a:p>
+            <a:r>
+              <a:rPr lang="en-US" sz="700" i="1" dirty="0">
+                <a:solidFill>
+                  <a:schemeClr val="tx1">
+                    <a:lumMod val="50000"/>
+                    <a:lumOff val="50000"/>
+                  </a:schemeClr>
+                </a:solidFill>
+              </a:rPr>
+              <a:t>the accepted model using fire history, land cover, terrain, and climate predictors</a:t>
+            </a:r>
+            <a:endParaRPr lang="en-US" sz="800" dirty="0"/>
           </a:p>
           <a:p>
             <a:pPr marL="0" indent="0">
@@ -7942,14 +7998,38 @@
               <a:buNone/>
             </a:pPr>
             <a:r>
-              <a:rPr sz="850">
+              <a:rPr sz="850" dirty="0">
                 <a:solidFill>
                   <a:srgbClr val="1A2638"/>
                 </a:solidFill>
               </a:rPr>
-              <a:t>MAE: 0.029  -&gt;  0.021</a:t>
-            </a:r>
-            <a:endParaRPr sz="850"/>
+              <a:t>MAE: 0.029</a:t>
+            </a:r>
+            <a:r>
+              <a:rPr lang="en-US" sz="850" dirty="0">
+                <a:solidFill>
+                  <a:srgbClr val="1A2638"/>
+                </a:solidFill>
+              </a:rPr>
+              <a:t>2</a:t>
+            </a:r>
+            <a:r>
+              <a:rPr sz="850" dirty="0">
+                <a:solidFill>
+                  <a:srgbClr val="1A2638"/>
+                </a:solidFill>
+              </a:rPr>
+              <a:t>  -&gt;  0.02</a:t>
+            </a:r>
+            <a:r>
+              <a:rPr lang="en-US" sz="850" dirty="0">
+                <a:solidFill>
+                  <a:srgbClr val="1A2638"/>
+                </a:solidFill>
+              </a:rPr>
+              <a:t>09</a:t>
+            </a:r>
+            <a:endParaRPr sz="850" dirty="0"/>
           </a:p>
         </p:txBody>
       </p:sp>
@@ -8061,14 +8141,38 @@
               <a:buNone/>
             </a:pPr>
             <a:r>
-              <a:rPr sz="850">
+              <a:rPr sz="850" dirty="0">
                 <a:solidFill>
                   <a:srgbClr val="1A2638"/>
                 </a:solidFill>
               </a:rPr>
-              <a:t>RMSE: 0.111  -&gt;  0.111</a:t>
-            </a:r>
-            <a:endParaRPr sz="850"/>
+              <a:t>RMSE: 0.11</a:t>
+            </a:r>
+            <a:r>
+              <a:rPr lang="en-US" sz="850" dirty="0">
+                <a:solidFill>
+                  <a:srgbClr val="1A2638"/>
+                </a:solidFill>
+              </a:rPr>
+              <a:t>06</a:t>
+            </a:r>
+            <a:r>
+              <a:rPr sz="850" dirty="0">
+                <a:solidFill>
+                  <a:srgbClr val="1A2638"/>
+                </a:solidFill>
+              </a:rPr>
+              <a:t>  -&gt;  0.111</a:t>
+            </a:r>
+            <a:r>
+              <a:rPr lang="en-US" sz="850" dirty="0">
+                <a:solidFill>
+                  <a:srgbClr val="1A2638"/>
+                </a:solidFill>
+              </a:rPr>
+              <a:t>0</a:t>
+            </a:r>
+            <a:endParaRPr sz="850" dirty="0"/>
           </a:p>
         </p:txBody>
       </p:sp>
@@ -8180,14 +8284,50 @@
               <a:buNone/>
             </a:pPr>
             <a:r>
-              <a:rPr sz="850">
+              <a:rPr sz="850" dirty="0">
                 <a:solidFill>
                   <a:srgbClr val="1A2638"/>
                 </a:solidFill>
               </a:rPr>
-              <a:t>Capture@20%: 0.482  -&gt;  0.500</a:t>
-            </a:r>
-            <a:endParaRPr sz="850"/>
+              <a:t>Capture@20%: </a:t>
+            </a:r>
+            <a:r>
+              <a:rPr lang="en-US" sz="850" dirty="0">
+                <a:solidFill>
+                  <a:srgbClr val="1A2638"/>
+                </a:solidFill>
+              </a:rPr>
+              <a:t>40.2%</a:t>
+            </a:r>
+            <a:r>
+              <a:rPr sz="850" dirty="0">
+                <a:solidFill>
+                  <a:srgbClr val="1A2638"/>
+                </a:solidFill>
+              </a:rPr>
+              <a:t>  -&gt;  </a:t>
+            </a:r>
+            <a:r>
+              <a:rPr lang="en-US" sz="850" dirty="0">
+                <a:solidFill>
+                  <a:srgbClr val="1A2638"/>
+                </a:solidFill>
+              </a:rPr>
+              <a:t>57.2%</a:t>
+            </a:r>
+          </a:p>
+          <a:p>
+            <a:r>
+              <a:rPr lang="en-US" sz="700" i="1" dirty="0">
+                <a:solidFill>
+                  <a:schemeClr val="tx1">
+                    <a:lumMod val="50000"/>
+                    <a:lumOff val="50000"/>
+                  </a:schemeClr>
+                </a:solidFill>
+              </a:rPr>
+              <a:t>how much observed burned share occurred within the highest-ranked 20% of cells</a:t>
+            </a:r>
           </a:p>
         </p:txBody>
       </p:sp>
@@ -8283,7 +8423,7 @@
         </p:nvSpPr>
         <p:spPr>
           <a:xfrm>
-            <a:off x="713232" y="4187952"/>
+            <a:off x="713232" y="4165092"/>
             <a:ext cx="3611880" cy="347472"/>
           </a:xfrm>
           <a:prstGeom prst="rect">
@@ -8295,18 +8435,10 @@
           <a:bodyPr wrap="square" lIns="0" tIns="0" rIns="0" bIns="0" anchor="ctr"/>
           <a:lstStyle/>
           <a:p>
-            <a:pPr marL="0" indent="0">
-              <a:buNone/>
-            </a:pPr>
-            <a:r>
-              <a:rPr sz="850">
-                <a:solidFill>
-                  <a:srgbClr val="1A2638"/>
-                </a:solidFill>
-              </a:rPr>
-              <a:t>Final temporal test: T=2022–2024; outcomes in T+1.</a:t>
-            </a:r>
-            <a:endParaRPr sz="850"/>
+            <a:r>
+              <a:rPr lang="en-US" sz="800" dirty="0"/>
+              <a:t>Final test: predictor years T=2022–2024; outcomes T+1=2023–2025</a:t>
+            </a:r>
           </a:p>
         </p:txBody>
       </p:sp>
@@ -8901,14 +9033,14 @@
               <a:buNone/>
             </a:pPr>
             <a:r>
-              <a:rPr sz="750" b="1">
+              <a:rPr sz="750" b="1" dirty="0">
                 <a:solidFill>
                   <a:srgbClr val="E8A020"/>
                 </a:solidFill>
               </a:rPr>
               <a:t>It is a ranking diagnostic, not a buyer threshold.</a:t>
             </a:r>
-            <a:endParaRPr sz="750"/>
+            <a:endParaRPr sz="750" dirty="0"/>
           </a:p>
         </p:txBody>
       </p:sp>
@@ -9890,14 +10022,14 @@
               <a:buNone/>
             </a:pPr>
             <a:r>
-              <a:rPr sz="2000" b="1">
+              <a:rPr lang="en-US" sz="2000" b="1" dirty="0">
                 <a:solidFill>
                   <a:srgbClr val="E8A020"/>
                 </a:solidFill>
               </a:rPr>
-              <a:t>→</a:t>
-            </a:r>
-            <a:endParaRPr sz="2000"/>
+              <a:t>-&gt;</a:t>
+            </a:r>
+            <a:endParaRPr sz="2000" dirty="0"/>
           </a:p>
         </p:txBody>
       </p:sp>
@@ -10297,14 +10429,14 @@
               <a:buNone/>
             </a:pPr>
             <a:r>
-              <a:rPr sz="2000" b="1">
+              <a:rPr lang="en-US" sz="2000" b="1" dirty="0">
                 <a:solidFill>
                   <a:srgbClr val="E8A020"/>
                 </a:solidFill>
               </a:rPr>
-              <a:t>→</a:t>
-            </a:r>
-            <a:endParaRPr sz="2000"/>
+              <a:t>-&gt;</a:t>
+            </a:r>
+            <a:endParaRPr sz="2000" dirty="0"/>
           </a:p>
         </p:txBody>
       </p:sp>
@@ -13634,14 +13766,14 @@
               <a:buNone/>
             </a:pPr>
             <a:r>
-              <a:rPr sz="2000" b="1">
+              <a:rPr lang="en-US" sz="2000" b="1" dirty="0">
                 <a:solidFill>
                   <a:srgbClr val="E8A020"/>
                 </a:solidFill>
               </a:rPr>
-              <a:t>→</a:t>
-            </a:r>
-            <a:endParaRPr sz="2000"/>
+              <a:t>-&gt;</a:t>
+            </a:r>
+            <a:endParaRPr sz="2000" dirty="0"/>
           </a:p>
         </p:txBody>
       </p:sp>
@@ -14041,14 +14173,14 @@
               <a:buNone/>
             </a:pPr>
             <a:r>
-              <a:rPr sz="2000" b="1">
+              <a:rPr lang="en-US" sz="2000" b="1" dirty="0">
                 <a:solidFill>
                   <a:srgbClr val="E8A020"/>
                 </a:solidFill>
               </a:rPr>
-              <a:t>→</a:t>
-            </a:r>
-            <a:endParaRPr sz="2000"/>
+              <a:t>-&gt;</a:t>
+            </a:r>
+            <a:endParaRPr sz="2000" dirty="0"/>
           </a:p>
         </p:txBody>
       </p:sp>

</xml_diff>

<commit_message>
PPTX file title updated
</commit_message>
<xml_diff>
--- a/reports/presentation/wildfire_exposure_screening_capstone_final.pptx
+++ b/reports/presentation/wildfire_exposure_screening_capstone_final.pptx
@@ -338,71 +338,32 @@
           <a:lstStyle/>
           <a:p>
             <a:r>
-              <a:rPr lang="en-US" dirty="0"/>
-              <a:t>This project combines validated wildfire history, landscape, terrain, climate, GIS, and machine learning to compare broad areas of mainland Portugal, helping a user narrow a location search before conducting local and property-specific checks.</a:t>
-            </a:r>
-            <a:br>
-              <a:rPr lang="en-US" dirty="0"/>
-            </a:br>
-            <a:endParaRPr lang="en-US" dirty="0"/>
-          </a:p>
-          <a:p>
-            <a:r>
-              <a:rPr lang="en-US" b="1" dirty="0"/>
-              <a:t>Main message:</a:t>
-            </a:r>
-            <a:r>
-              <a:rPr lang="en-US" dirty="0"/>
-              <a:t> The project helps </a:t>
-            </a:r>
-            <a:r>
-              <a:rPr lang="en-US" dirty="0" err="1"/>
-              <a:t>organise</a:t>
-            </a:r>
-            <a:r>
-              <a:rPr lang="en-US" dirty="0"/>
-              <a:t> broad location research; it does not decide whether to buy a property.</a:t>
-            </a:r>
-          </a:p>
-          <a:p>
-            <a:endParaRPr lang="en-US" dirty="0"/>
-          </a:p>
-          <a:p>
-            <a:r>
-              <a:rPr lang="en-US" b="1" dirty="0"/>
+              <a:rPr dirty="0"/>
+              <a:t>Main message: This capstone uses reproducible wildfire-exposure evidence to help narrow broad location-search areas in mainland Portugal.</a:t>
+            </a:r>
+          </a:p>
+          <a:p>
+            <a:endParaRPr dirty="0"/>
+          </a:p>
+          <a:p>
+            <a:r>
+              <a:rPr b="1" dirty="0"/>
               <a:t>What to say:</a:t>
             </a:r>
-            <a:endParaRPr lang="en-US" dirty="0"/>
-          </a:p>
-          <a:p>
-            <a:r>
-              <a:rPr lang="en-US" dirty="0"/>
-              <a:t>“People considering locations across mainland Portugal face a very broad search problem. Wildfire exposure is one factor that may matter, but it is difficult to compare areas fairly using isolated past fire events.</a:t>
-            </a:r>
-          </a:p>
-          <a:p>
-            <a:r>
-              <a:rPr lang="en-US" dirty="0"/>
-              <a:t>This capstone creates a reproducible GIS and machine-learning workflow for that first screening stage. It combines observed wildfire history, landscape, terrain, and climate information to compare 1 km areas across mainland Portugal.</a:t>
-            </a:r>
-          </a:p>
-          <a:p>
-            <a:r>
-              <a:rPr lang="en-US" dirty="0"/>
-              <a:t>The output is not a statement that an area is safe or unsafe, and it is not a buy-or-do-not-buy recommendation. Its purpose is to narrow a national search to areas that deserve more detailed local investigation.”</a:t>
-            </a:r>
-          </a:p>
-          <a:p>
-            <a:endParaRPr lang="en-US" dirty="0"/>
-          </a:p>
-          <a:p>
-            <a:r>
-              <a:rPr lang="en-US" b="1" dirty="0"/>
-              <a:t>Transition:</a:t>
-            </a:r>
-            <a:r>
-              <a:rPr lang="en-US" dirty="0"/>
-              <a:t> “To make those comparisons fair, I first needed one consistent unit of analysis and clearly defined source roles.”</a:t>
+          </a:p>
+          <a:p>
+            <a:r>
+              <a:rPr b="0" dirty="0"/>
+              <a:t>“The project does not identify a safe property or tell someone to buy or not buy. It combines observed wildfire history, landscape, terrain, climate, machine learning and GIS to compare broad areas consistently. The practical output is a shortlist for deeper local research before a property decision.”</a:t>
+            </a:r>
+          </a:p>
+          <a:p>
+            <a:endParaRPr dirty="0"/>
+          </a:p>
+          <a:p>
+            <a:r>
+              <a:rPr dirty="0"/>
+              <a:t>Transition: “Next, I will show what one consistent national record represents and how the source data are used.”</a:t>
             </a:r>
           </a:p>
           <a:p>
@@ -416,8 +377,8 @@
           </a:p>
           <a:p>
             <a:r>
-              <a:rPr dirty="0"/>
-              <a:t>Project README; docs/project_brief.md</a:t>
+              <a:rPr b="0" dirty="0"/>
+              <a:t>README.md; docs/project_brief.md; docs/data_dictionary.md</a:t>
             </a:r>
           </a:p>
         </p:txBody>
@@ -494,66 +455,66 @@
           <a:lstStyle/>
           <a:p>
             <a:r>
-              <a:rPr lang="en-US" b="1" dirty="0"/>
+              <a:rPr b="1" dirty="0"/>
               <a:t>Main message:</a:t>
             </a:r>
             <a:r>
-              <a:rPr lang="en-US" dirty="0"/>
+              <a:rPr dirty="0"/>
               <a:t> Every record has the same geographical meaning: one 1 km mainland cell in one predictor year.</a:t>
             </a:r>
             <a:br>
-              <a:rPr lang="en-US" dirty="0"/>
+              <a:rPr dirty="0"/>
             </a:br>
-            <a:endParaRPr lang="en-US" dirty="0"/>
-          </a:p>
-          <a:p>
-            <a:r>
-              <a:rPr lang="en-US" b="1" dirty="0"/>
+            <a:endParaRPr dirty="0"/>
+          </a:p>
+          <a:p>
+            <a:r>
+              <a:rPr b="1" dirty="0"/>
               <a:t>What to say:</a:t>
             </a:r>
-            <a:endParaRPr lang="en-US" dirty="0"/>
-          </a:p>
-          <a:p>
-            <a:r>
-              <a:rPr lang="en-US" dirty="0"/>
+            <a:endParaRPr dirty="0"/>
+          </a:p>
+          <a:p>
+            <a:r>
+              <a:rPr dirty="0"/>
               <a:t>“Each row in the analytical dataset represents one 1 km by 1 km mainland Portugal cell in a predictor year, T. This makes it possible to compare the same geographical unit over time.</a:t>
             </a:r>
           </a:p>
           <a:p>
             <a:r>
-              <a:rPr lang="en-US" dirty="0"/>
+              <a:rPr dirty="0"/>
               <a:t>ICNF annual burned-area data provides two roles: historical fire recurrence and the observed next-year outcome. The outcome is continuous burned share: the proportion of the cell’s land area that burned in the following year.</a:t>
             </a:r>
           </a:p>
           <a:p>
             <a:r>
-              <a:rPr lang="en-US" dirty="0"/>
+              <a:rPr dirty="0"/>
               <a:t>CLC land cover and Copernicus DEM provide landscape and terrain context. ERA5-Land provides warm-season temperature, precipitation, and shallow soil-water conditions from the predictor year only.</a:t>
             </a:r>
           </a:p>
           <a:p>
             <a:r>
-              <a:rPr lang="en-US" dirty="0"/>
+              <a:rPr dirty="0"/>
               <a:t>The 2 km area is not a second grid. It is an outward context buffer around each 1 km cell, used to measure nearby forest/shrub, slope, and historical fire recurrence.”</a:t>
             </a:r>
             <a:br>
-              <a:rPr lang="en-US" dirty="0"/>
+              <a:rPr dirty="0"/>
             </a:br>
-            <a:endParaRPr lang="en-US" dirty="0"/>
-          </a:p>
-          <a:p>
-            <a:r>
-              <a:rPr lang="en-US" b="1" dirty="0"/>
+            <a:endParaRPr dirty="0"/>
+          </a:p>
+          <a:p>
+            <a:r>
+              <a:rPr b="1" dirty="0"/>
               <a:t>Transition:</a:t>
             </a:r>
             <a:r>
-              <a:rPr lang="en-US" dirty="0"/>
+              <a:rPr dirty="0"/>
               <a:t> “With that common structure, the first result is that wildfire history is not evenly distributed across the country.”</a:t>
             </a:r>
             <a:br>
-              <a:rPr lang="en-US" dirty="0"/>
+              <a:rPr dirty="0"/>
             </a:br>
-            <a:endParaRPr lang="en-US" dirty="0"/>
+            <a:endParaRPr dirty="0"/>
           </a:p>
           <a:p>
             <a:r>
@@ -642,98 +603,72 @@
           <a:lstStyle/>
           <a:p>
             <a:r>
-              <a:rPr lang="en-US" b="1" dirty="0"/>
+              <a:rPr b="1"/>
               <a:t>Main message:</a:t>
             </a:r>
             <a:r>
-              <a:rPr lang="en-US" dirty="0"/>
               <a:t> Wildfire exposure patterns vary geographically, so a national location search can be narrowed using comparative evidence.</a:t>
             </a:r>
-            <a:endParaRPr dirty="0"/>
-          </a:p>
-          <a:p>
-            <a:r>
-              <a:rPr dirty="0"/>
+          </a:p>
+          <a:p>
+            <a:r>
               <a:t>These layers provide different types of evidence and should not be added together or interpreted as one score. The comparison helps identify broad areas for further investigation; it does not certify a location.</a:t>
             </a:r>
-            <a:br>
-              <a:rPr lang="en-US" dirty="0"/>
-            </a:br>
-            <a:br>
-              <a:rPr lang="en-US" dirty="0"/>
-            </a:br>
-            <a:r>
-              <a:rPr lang="en-US" b="1" dirty="0"/>
+            <a:br/>
+            <a:br/>
+            <a:r>
+              <a:rPr b="1"/>
               <a:t>What to say:</a:t>
             </a:r>
-            <a:endParaRPr lang="en-US" dirty="0"/>
-          </a:p>
-          <a:p>
-            <a:r>
-              <a:rPr lang="en-US" dirty="0"/>
+            <a:endParaRPr/>
+          </a:p>
+          <a:p>
+            <a:r>
               <a:t>“This slide shows three different views of the same national geography.</a:t>
             </a:r>
           </a:p>
           <a:p>
             <a:r>
-              <a:rPr lang="en-US" dirty="0"/>
               <a:t>The first map shows observed historical recurrence: how many distinct years had burned-area evidence between 2016 and 2025 within the 2 km context around each 1 km cell.</a:t>
             </a:r>
           </a:p>
           <a:p>
             <a:r>
-              <a:rPr lang="en-US" dirty="0"/>
               <a:t>The second map is the ICNF and official Portuguese government map showing where the landscape has more or less underlying potential to support severe wildfire conditions. It describes persistent landscape hazard conditions rather than what burned in one particular year.</a:t>
             </a:r>
           </a:p>
           <a:p>
             <a:r>
-              <a:rPr lang="en-US" dirty="0"/>
               <a:t>The third map is the project’s 2026 comparative estimate. It uses information available through 2025 to rank 1 km cells by estimated next-year burned share.</a:t>
             </a:r>
           </a:p>
           <a:p>
             <a:r>
-              <a:rPr lang="en-US" dirty="0"/>
               <a:t>These maps should not be added together into one score. They provide different evidence for comparing broad areas and deciding where additional research is worthwhile.”</a:t>
             </a:r>
           </a:p>
           <a:p>
-            <a:endParaRPr lang="en-US" dirty="0"/>
-          </a:p>
-          <a:p>
-            <a:r>
-              <a:rPr lang="en-US" b="1" dirty="0"/>
+            <a:endParaRPr/>
+          </a:p>
+          <a:p>
+            <a:r>
+              <a:rPr b="1"/>
               <a:t>Transition:</a:t>
             </a:r>
             <a:r>
-              <a:rPr lang="en-US" dirty="0"/>
               <a:t> “Because historical recurrence and official structural hazard measure different things, the next question is why it is useful to compare them.”</a:t>
             </a:r>
-            <a:endParaRPr dirty="0"/>
-          </a:p>
-          <a:p>
-            <a:endParaRPr dirty="0"/>
-          </a:p>
-          <a:p>
-            <a:r>
-              <a:rPr dirty="0"/>
+          </a:p>
+          <a:p>
+            <a:endParaRPr/>
+          </a:p>
+          <a:p>
+            <a:r>
               <a:t>[Sources]</a:t>
             </a:r>
-            <a:br>
-              <a:rPr dirty="0"/>
-            </a:br>
-            <a:r>
-              <a:rPr dirty="0"/>
-              <a:t>reports/figures/historical_wildfire_exposure_screening_mainland_portugal.png; reports/validation/historical_exposure_screening_and_icnf_comparison.md; </a:t>
-            </a:r>
-            <a:r>
-              <a:rPr dirty="0" err="1"/>
-              <a:t>qgis</a:t>
-            </a:r>
-            <a:r>
-              <a:rPr dirty="0"/>
-              <a:t>/README.md; reports/validation/operational_forecast_2026_validation.md</a:t>
+            <a:br/>
+            <a:r>
+              <a:t>reports/figures/historical_wildfire_exposure_screening_mainland_portugal.png; reports/validation/historical_exposure_screening_and_icnf_comparison.md; qgis/README.md; reports/validation/operational_forecast_2026_validation.md</a:t>
             </a:r>
           </a:p>
         </p:txBody>
@@ -810,79 +745,65 @@
           <a:lstStyle/>
           <a:p>
             <a:r>
-              <a:rPr lang="en-US" b="1" dirty="0"/>
+              <a:rPr b="1"/>
               <a:t>Main message:</a:t>
             </a:r>
             <a:r>
-              <a:rPr lang="en-US" dirty="0"/>
               <a:t> Observed recurrence and official structural hazard are complementary, not competing, evidence layers.</a:t>
             </a:r>
           </a:p>
           <a:p>
-            <a:endParaRPr lang="en-US" dirty="0"/>
-          </a:p>
-          <a:p>
-            <a:r>
-              <a:rPr lang="en-US" b="1" dirty="0"/>
+            <a:endParaRPr/>
+          </a:p>
+          <a:p>
+            <a:r>
+              <a:rPr b="1"/>
               <a:t>What to say:</a:t>
             </a:r>
-            <a:endParaRPr lang="en-US" dirty="0"/>
-          </a:p>
-          <a:p>
-            <a:r>
-              <a:rPr lang="en-US" dirty="0"/>
+            <a:endParaRPr/>
+          </a:p>
+          <a:p>
+            <a:r>
               <a:t>“Historical recurrence answers: ‘What burned repeatedly in the observed 2016–2025 period?’ It is based on annual burned-area records.</a:t>
             </a:r>
           </a:p>
           <a:p>
             <a:r>
-              <a:rPr lang="en-US" dirty="0"/>
               <a:t>Official ICNF structural hazard answers a different question: ‘What persistent landscape conditions are associated with wildfire hazard?’ Its source is an official 25 m classification, summarized here to the predominant class for each 1 km cell.</a:t>
             </a:r>
           </a:p>
           <a:p>
             <a:r>
-              <a:rPr lang="en-US" dirty="0"/>
               <a:t>Where the layers agree, they provide consistent broad-area context. Where they differ, they identify areas where the historical record and structural landscape conditions tell a more nuanced story.</a:t>
             </a:r>
           </a:p>
           <a:p>
             <a:r>
-              <a:rPr lang="en-US" dirty="0"/>
               <a:t>This comparison is descriptive. It is not a model-accuracy test, and neither layer is a threshold for deciding whether a particular property is acceptable.”</a:t>
             </a:r>
           </a:p>
           <a:p>
-            <a:endParaRPr lang="en-US" dirty="0"/>
-          </a:p>
-          <a:p>
-            <a:r>
-              <a:rPr lang="en-US" b="1" dirty="0"/>
+            <a:endParaRPr/>
+          </a:p>
+          <a:p>
+            <a:r>
+              <a:rPr b="1"/>
               <a:t>Transition:</a:t>
             </a:r>
             <a:r>
-              <a:rPr lang="en-US" dirty="0"/>
               <a:t> “Historical context is useful, but I also tested whether a data-driven model could improve next-year comparative estimates.”</a:t>
             </a:r>
           </a:p>
           <a:p>
-            <a:endParaRPr dirty="0"/>
-          </a:p>
-          <a:p>
-            <a:r>
-              <a:rPr dirty="0"/>
+            <a:endParaRPr/>
+          </a:p>
+          <a:p>
+            <a:r>
               <a:t>[Sources]</a:t>
             </a:r>
-            <a:br>
-              <a:rPr dirty="0"/>
-            </a:br>
-            <a:r>
-              <a:rPr dirty="0" err="1"/>
-              <a:t>qgis</a:t>
-            </a:r>
-            <a:r>
-              <a:rPr dirty="0"/>
-              <a:t>/README.md; docs/data_dictionary.md; reports/figures/historical_exposure_by_icnf_structural_hazard_crosstab.png</a:t>
+            <a:br/>
+            <a:r>
+              <a:t>qgis/README.md; docs/data_dictionary.md; reports/figures/historical_exposure_by_icnf_structural_hazard_crosstab.png</a:t>
             </a:r>
           </a:p>
         </p:txBody>
@@ -959,231 +880,175 @@
           <a:lstStyle/>
           <a:p>
             <a:r>
-              <a:rPr lang="en-US" b="1" dirty="0"/>
+              <a:rPr b="1"/>
               <a:t>Main message:</a:t>
             </a:r>
             <a:r>
-              <a:rPr lang="en-US" dirty="0"/>
               <a:t> The nine-feature two-stage regression improves average comparative error and burned-share ranking over historical recurrence alone, while extreme fire outcomes remain difficult.</a:t>
             </a:r>
           </a:p>
           <a:p>
-            <a:endParaRPr lang="en-US" b="1" dirty="0"/>
-          </a:p>
-          <a:p>
-            <a:r>
-              <a:rPr lang="en-US" b="1" dirty="0"/>
+            <a:endParaRPr b="1"/>
+          </a:p>
+          <a:p>
+            <a:r>
+              <a:rPr b="1"/>
               <a:t>What to say:</a:t>
             </a:r>
-            <a:br>
-              <a:rPr lang="en-US" dirty="0"/>
-            </a:br>
-            <a:r>
-              <a:rPr lang="en-US" dirty="0"/>
-              <a:t>“This slide compares two approaches using the held-out final period: predictor </a:t>
-            </a:r>
-            <a:r>
-              <a:rPr lang="en-US"/>
-              <a:t>years </a:t>
-            </a:r>
-            <a:r>
-              <a:rPr lang="en-US" b="1"/>
+            <a:br/>
+            <a:r>
+              <a:t>“This slide compares two approaches using the held-out final period: predictor years </a:t>
+            </a:r>
+            <a:r>
+              <a:rPr b="1"/>
               <a:t>2022 - 2024</a:t>
             </a:r>
             <a:r>
-              <a:rPr lang="en-US"/>
-              <a:t> </a:t>
-            </a:r>
-            <a:r>
-              <a:rPr lang="en-US" dirty="0"/>
-              <a:t>and observed outcomes </a:t>
-            </a:r>
-            <a:r>
-              <a:rPr lang="en-US" b="1" dirty="0"/>
-              <a:t>2023</a:t>
-            </a:r>
-            <a:r>
-              <a:rPr lang="ru-RU" b="1" dirty="0"/>
-              <a:t> - </a:t>
-            </a:r>
-            <a:r>
-              <a:rPr lang="en-US" b="1" dirty="0"/>
-              <a:t>2025</a:t>
-            </a:r>
-            <a:r>
-              <a:rPr lang="en-US" dirty="0"/>
+              <a:t> and observed outcomes </a:t>
+            </a:r>
+            <a:r>
+              <a:rPr b="1"/>
+              <a:t>2023 - 2025</a:t>
+            </a:r>
+            <a:r>
               <a:t>.</a:t>
             </a:r>
           </a:p>
           <a:p>
             <a:r>
-              <a:rPr lang="en-US" dirty="0"/>
               <a:t>The historical-recurrence baseline is a transparent project benchmark. It groups training records by the number of previously burned years in the 2 km context and uses the training-period average next-year burned share for each group. It is an empirical project benchmark, not a library model.</a:t>
             </a:r>
           </a:p>
           <a:p>
             <a:r>
-              <a:rPr lang="en-US" dirty="0"/>
-              <a:t>The nine-feature Model V2 uses two </a:t>
-            </a:r>
-            <a:r>
-              <a:rPr lang="en-US" dirty="0" err="1"/>
-              <a:t>HistGradientBoosting</a:t>
-            </a:r>
-            <a:r>
-              <a:rPr lang="en-US" dirty="0"/>
-              <a:t> components. The first estimates whether burning is likely in a cell. The second estimates how much of the cell’s land area may burn when burning occurs. These two parts are combined into one continuous estimated burned share.</a:t>
-            </a:r>
-          </a:p>
-          <a:p>
-            <a:r>
-              <a:rPr lang="en-US" dirty="0"/>
+              <a:t>The nine-feature Model V2 uses two HistGradientBoosting components. The first estimates whether burning is likely in a cell. The second estimates how much of the cell’s land area may burn when burning occurs. These two parts are combined into one continuous estimated burned share.</a:t>
+            </a:r>
+          </a:p>
+          <a:p>
+            <a:r>
               <a:t>On the final test, Model V2 lowers MAE from </a:t>
             </a:r>
             <a:r>
-              <a:rPr lang="en-US" b="1" dirty="0"/>
+              <a:rPr b="1"/>
               <a:t>0.0292 to 0.0209</a:t>
             </a:r>
             <a:r>
-              <a:rPr lang="en-US" dirty="0"/>
               <a:t>. RMSE is almost unchanged but slightly higher, from </a:t>
             </a:r>
             <a:r>
-              <a:rPr lang="en-US" b="1" dirty="0"/>
+              <a:rPr b="1"/>
               <a:t>0.1106 to 0.1110</a:t>
             </a:r>
             <a:r>
-              <a:rPr lang="en-US" dirty="0"/>
               <a:t>, showing that larger and more extreme fire outcomes remain difficult.”</a:t>
             </a:r>
           </a:p>
           <a:p>
-            <a:endParaRPr lang="en-US" dirty="0"/>
-          </a:p>
-          <a:p>
-            <a:r>
-              <a:rPr lang="en-US" b="1" dirty="0"/>
+            <a:endParaRPr/>
+          </a:p>
+          <a:p>
+            <a:r>
+              <a:rPr b="1"/>
               <a:t>Capture@20% is a validation test of the ranking.</a:t>
             </a:r>
             <a:r>
-              <a:rPr lang="en-US" dirty="0"/>
               <a:t> For each predictor year, the model ranks cells using information from year </a:t>
             </a:r>
             <a:r>
-              <a:rPr lang="en-US" b="1" dirty="0"/>
+              <a:rPr b="1"/>
               <a:t>T</a:t>
             </a:r>
             <a:r>
-              <a:rPr lang="en-US" dirty="0"/>
               <a:t> and estimates burned share for </a:t>
             </a:r>
             <a:r>
-              <a:rPr lang="en-US" b="1" dirty="0"/>
+              <a:rPr b="1"/>
               <a:t>T+1</a:t>
             </a:r>
             <a:r>
-              <a:rPr lang="en-US" dirty="0"/>
               <a:t>. For example, for </a:t>
             </a:r>
             <a:r>
-              <a:rPr lang="en-US" b="1" dirty="0"/>
+              <a:rPr b="1"/>
               <a:t>2024 -&gt; 2025</a:t>
             </a:r>
             <a:r>
-              <a:rPr lang="en-US" dirty="0"/>
               <a:t>, it ranks cells using 2024 predictor data and is later checked against observed ICNF burned areas from 2025.</a:t>
             </a:r>
           </a:p>
           <a:p>
             <a:r>
-              <a:rPr lang="en-US" dirty="0"/>
               <a:t>The final evaluation covers </a:t>
             </a:r>
             <a:r>
-              <a:rPr lang="en-US" b="1" dirty="0"/>
+              <a:rPr b="1"/>
               <a:t>2022 -&gt; 2023, 2023 -&gt; 2024, and 2024 -&gt; 2025</a:t>
             </a:r>
             <a:r>
-              <a:rPr lang="en-US" dirty="0"/>
               <a:t>. We select the highest-scored 20% of cells and measure how much of the total observed burned-share mass occurred within those cells.</a:t>
             </a:r>
           </a:p>
           <a:p>
             <a:r>
-              <a:rPr lang="en-US" dirty="0"/>
               <a:t>Across the final test, the historical baseline captured </a:t>
             </a:r>
             <a:r>
-              <a:rPr lang="en-US" b="1" dirty="0"/>
+              <a:rPr b="1"/>
               <a:t>40.2%</a:t>
             </a:r>
             <a:r>
-              <a:rPr lang="en-US" dirty="0"/>
               <a:t> of observed burned-share mass in its top-ranked 20% of cells. Model V2 captured </a:t>
             </a:r>
             <a:r>
-              <a:rPr lang="en-US" b="1" dirty="0"/>
+              <a:rPr b="1"/>
               <a:t>57.2%</a:t>
             </a:r>
             <a:r>
-              <a:rPr lang="en-US" dirty="0"/>
               <a:t>.</a:t>
             </a:r>
           </a:p>
           <a:p>
             <a:r>
-              <a:rPr lang="en-US" dirty="0"/>
               <a:t>This does not mean that 20% of the land burned. It is a retrospective ranking diagnostic, not a buyer threshold or a property-level forecast. The same logic could later be applied to </a:t>
             </a:r>
             <a:r>
-              <a:rPr lang="en-US" b="1" dirty="0"/>
+              <a:rPr b="1"/>
               <a:t>2035 -&gt; 2036</a:t>
             </a:r>
             <a:r>
-              <a:rPr lang="en-US" dirty="0"/>
               <a:t>, but only after the 2036 outcome data become available.”</a:t>
             </a:r>
           </a:p>
           <a:p>
-            <a:endParaRPr lang="en-US" dirty="0"/>
-          </a:p>
-          <a:p>
-            <a:r>
-              <a:rPr lang="en-US" b="1" dirty="0"/>
+            <a:endParaRPr/>
+          </a:p>
+          <a:p>
+            <a:r>
+              <a:rPr b="1"/>
               <a:t>Transition:</a:t>
             </a:r>
             <a:r>
-              <a:rPr lang="en-US" dirty="0"/>
               <a:t> “The practical question is whether the model provides a useful ranking for broad-area screening.”</a:t>
             </a:r>
           </a:p>
           <a:p>
-            <a:endParaRPr lang="en-US" b="1" dirty="0"/>
-          </a:p>
-          <a:p>
-            <a:r>
-              <a:rPr lang="en-US" b="1" dirty="0"/>
+            <a:endParaRPr b="1"/>
+          </a:p>
+          <a:p>
+            <a:r>
+              <a:rPr b="1"/>
               <a:t>[Sources]</a:t>
             </a:r>
-            <a:br>
-              <a:rPr lang="en-US" dirty="0"/>
-            </a:br>
-            <a:r>
-              <a:rPr lang="en-US" dirty="0"/>
+            <a:br/>
+            <a:r>
               <a:t>reports/validation/model_final_decision.md</a:t>
             </a:r>
-            <a:br>
-              <a:rPr lang="en-US" dirty="0"/>
-            </a:br>
-            <a:r>
-              <a:rPr lang="en-US" dirty="0"/>
+            <a:br/>
+            <a:r>
               <a:t>reports/validation/final_temporal_test_2022_2024.md</a:t>
             </a:r>
-            <a:br>
-              <a:rPr lang="en-US" dirty="0"/>
-            </a:br>
-            <a:r>
-              <a:rPr lang="en-US" dirty="0"/>
+            <a:br/>
+            <a:r>
               <a:t>reports/figures/model_final_test_metric_comparison.png</a:t>
             </a:r>
           </a:p>
@@ -1261,80 +1126,61 @@
           <a:lstStyle/>
           <a:p>
             <a:r>
-              <a:rPr lang="en-US" b="1" dirty="0"/>
+              <a:rPr b="1"/>
               <a:t>Main message:</a:t>
             </a:r>
             <a:r>
-              <a:rPr lang="en-US" dirty="0"/>
               <a:t> The output supports shortlisting broad areas, not choosing a property.</a:t>
             </a:r>
           </a:p>
           <a:p>
-            <a:endParaRPr lang="en-US" dirty="0"/>
-          </a:p>
-          <a:p>
-            <a:r>
-              <a:rPr lang="en-US" b="1" dirty="0"/>
+            <a:endParaRPr/>
+          </a:p>
+          <a:p>
+            <a:r>
+              <a:rPr b="1"/>
               <a:t>What to say:</a:t>
             </a:r>
-            <a:endParaRPr lang="en-US" dirty="0"/>
-          </a:p>
-          <a:p>
-            <a:r>
-              <a:rPr lang="en-US" dirty="0"/>
+            <a:endParaRPr/>
+          </a:p>
+          <a:p>
+            <a:r>
               <a:t>“Imagine a buyer considering multiple regions across mainland Portugal.</a:t>
             </a:r>
           </a:p>
           <a:p>
             <a:r>
-              <a:rPr lang="en-US" dirty="0"/>
               <a:t>They begin with the 2026 comparative estimate to compare broad 1 km areas using 2025 predictor inputs. They then look alongside it at observed historical recurrence and the official ICNF structural-hazard layer.</a:t>
             </a:r>
           </a:p>
           <a:p>
             <a:r>
-              <a:rPr lang="en-US" dirty="0"/>
               <a:t>The result is not a chosen property. It is a smaller, more structured set of broad areas for further research, site visits, and local checks.”</a:t>
             </a:r>
           </a:p>
           <a:p>
-            <a:endParaRPr lang="en-US" dirty="0"/>
-          </a:p>
-          <a:p>
-            <a:r>
-              <a:rPr lang="en-US" b="1" dirty="0"/>
+            <a:endParaRPr/>
+          </a:p>
+          <a:p>
+            <a:r>
+              <a:rPr b="1"/>
               <a:t>Transition:</a:t>
             </a:r>
             <a:r>
-              <a:rPr lang="en-US" dirty="0"/>
               <a:t> “The next slide explains the two safeguards that keep this use case responsible.”</a:t>
             </a:r>
           </a:p>
           <a:p>
-            <a:endParaRPr dirty="0"/>
-          </a:p>
-          <a:p>
-            <a:r>
-              <a:rPr dirty="0"/>
+            <a:endParaRPr/>
+          </a:p>
+          <a:p>
+            <a:r>
               <a:t>[Sources]</a:t>
             </a:r>
           </a:p>
           <a:p>
             <a:r>
-              <a:rPr dirty="0" err="1"/>
-              <a:t>qgis</a:t>
-            </a:r>
-            <a:r>
-              <a:rPr dirty="0"/>
-              <a:t>/wildfire_exposure_screening_portugal_2026.qgz; </a:t>
-            </a:r>
-            <a:r>
-              <a:rPr dirty="0" err="1"/>
-              <a:t>qgis</a:t>
-            </a:r>
-            <a:r>
-              <a:rPr dirty="0"/>
-              <a:t>/README.md; reports/validation/operational_forecast_2026_validation.md</a:t>
+              <a:t>qgis/wildfire_exposure_screening_portugal_2026.qgz; qgis/README.md; reports/validation/operational_forecast_2026_validation.md</a:t>
             </a:r>
           </a:p>
         </p:txBody>
@@ -1411,72 +1257,61 @@
           <a:lstStyle/>
           <a:p>
             <a:r>
-              <a:rPr lang="en-US" b="1" dirty="0"/>
+              <a:rPr b="1"/>
               <a:t>Main message:</a:t>
             </a:r>
             <a:r>
-              <a:rPr lang="en-US" dirty="0"/>
               <a:t> Compare layers first; then replace broad evidence with local evidence.</a:t>
             </a:r>
           </a:p>
           <a:p>
-            <a:endParaRPr lang="en-US" dirty="0"/>
-          </a:p>
-          <a:p>
-            <a:r>
-              <a:rPr lang="en-US" b="1" dirty="0"/>
+            <a:endParaRPr/>
+          </a:p>
+          <a:p>
+            <a:r>
+              <a:rPr b="1"/>
               <a:t>What to say:</a:t>
             </a:r>
-            <a:endParaRPr lang="en-US" dirty="0"/>
-          </a:p>
-          <a:p>
-            <a:r>
-              <a:rPr lang="en-US" dirty="0"/>
+            <a:endParaRPr/>
+          </a:p>
+          <a:p>
+            <a:r>
               <a:t>“The first recommendation is to compare the three layers separately: the 2026 comparative estimate, observed historical recurrence, and official ICNF structural hazard. They answer different questions, so they should not be merged into a single score.</a:t>
             </a:r>
           </a:p>
           <a:p>
             <a:r>
-              <a:rPr lang="en-US" dirty="0"/>
               <a:t>The second recommendation is local verification. Once an area is shortlisted, the decision should use planning restrictions, access and evacuation conditions, insurance, vegetation management, terrain, infrastructure, and property-specific information.</a:t>
             </a:r>
           </a:p>
           <a:p>
             <a:r>
-              <a:rPr lang="en-US" dirty="0"/>
               <a:t>The model helps direct research effort. It does not replace local investigation or certify a location.”</a:t>
             </a:r>
           </a:p>
           <a:p>
-            <a:endParaRPr lang="en-US" dirty="0"/>
-          </a:p>
-          <a:p>
-            <a:r>
-              <a:rPr lang="en-US" b="1" dirty="0"/>
+            <a:endParaRPr/>
+          </a:p>
+          <a:p>
+            <a:r>
+              <a:rPr b="1"/>
               <a:t>Transition:</a:t>
             </a:r>
             <a:r>
-              <a:rPr lang="en-US" dirty="0"/>
               <a:t> “Finally, the value of the project is not only one 2026 map -it is a repeatable annual workflow.”</a:t>
             </a:r>
           </a:p>
           <a:p>
-            <a:endParaRPr dirty="0"/>
-          </a:p>
-          <a:p>
-            <a:r>
-              <a:rPr dirty="0"/>
+            <a:endParaRPr/>
+          </a:p>
+          <a:p>
+            <a:r>
               <a:t>[Sources]</a:t>
             </a:r>
           </a:p>
           <a:p>
             <a:r>
-              <a:rPr dirty="0" err="1"/>
-              <a:t>qgis</a:t>
-            </a:r>
-            <a:r>
-              <a:rPr dirty="0"/>
-              <a:t>/README.md; docs/data_dictionary.md; reports/validation/historical_exposure_screening_and_icnf_comparison.md</a:t>
+              <a:t>qgis/README.md; docs/data_dictionary.md; reports/validation/historical_exposure_screening_and_icnf_comparison.md</a:t>
             </a:r>
           </a:p>
         </p:txBody>
@@ -1553,60 +1388,53 @@
           <a:lstStyle/>
           <a:p>
             <a:r>
-              <a:rPr lang="en-US" b="1" dirty="0"/>
+              <a:rPr b="1"/>
               <a:t>Main message:</a:t>
             </a:r>
             <a:r>
-              <a:rPr lang="en-US" dirty="0"/>
               <a:t> The project is successful as a reproducible comparative screening workflow with explicit limitations and an annual refresh path.</a:t>
             </a:r>
           </a:p>
           <a:p>
-            <a:endParaRPr lang="en-US" dirty="0"/>
-          </a:p>
-          <a:p>
-            <a:r>
-              <a:rPr lang="en-US" b="1" dirty="0"/>
+            <a:endParaRPr/>
+          </a:p>
+          <a:p>
+            <a:r>
+              <a:rPr b="1"/>
               <a:t>What to say:</a:t>
             </a:r>
-            <a:endParaRPr lang="en-US" dirty="0"/>
-          </a:p>
-          <a:p>
-            <a:r>
-              <a:rPr lang="en-US" dirty="0"/>
+            <a:endParaRPr/>
+          </a:p>
+          <a:p>
+            <a:r>
               <a:t>“This project delivered a reproducible national workflow: validated source data, a consistent 1 km grid, GIS outputs, historical evidence layers, and a tested nine-feature machine-learning model.</a:t>
             </a:r>
           </a:p>
           <a:p>
             <a:r>
-              <a:rPr lang="en-US" dirty="0"/>
               <a:t>The model provides a modest improvement over historical recurrence alone for selected comparative diagnostics. At the same time, the evaluation shows that extreme fire outcomes remain difficult, so the output must remain a cautious broad-area estimate.</a:t>
             </a:r>
           </a:p>
           <a:p>
             <a:r>
-              <a:rPr lang="en-US" dirty="0"/>
               <a:t>The practical result is a more focused location search. The annual next step is straightforward: when completed-year source data and the observed outcome for the prior estimate become available, rerun the fixed workflow, evaluate that estimate, and produce the next annual comparative layer.</a:t>
             </a:r>
           </a:p>
           <a:p>
             <a:r>
-              <a:rPr lang="en-US" dirty="0"/>
               <a:t>The project therefore provides a repeatable evidence process—not a final property decision.”</a:t>
             </a:r>
           </a:p>
           <a:p>
-            <a:endParaRPr dirty="0"/>
-          </a:p>
-          <a:p>
-            <a:r>
-              <a:rPr dirty="0"/>
+            <a:endParaRPr/>
+          </a:p>
+          <a:p>
+            <a:r>
               <a:t>[Sources]</a:t>
             </a:r>
           </a:p>
           <a:p>
             <a:r>
-              <a:rPr dirty="0"/>
               <a:t>README.md; reports/validation/model_final_decision.md; reports/validation/operational_forecast_readiness.md</a:t>
             </a:r>
           </a:p>
@@ -2143,7 +1971,7 @@
                   <a:srgbClr val="E1E8EF"/>
                 </a:solidFill>
               </a:rPr>
-              <a:t>DATA SCIENCE &amp; ML CAPSTONE</a:t>
+              <a:t>DATA SCIENCE · ML · GIS</a:t>
             </a:r>
             <a:endParaRPr sz="750"/>
           </a:p>
@@ -2319,7 +2147,7 @@
                   <a:srgbClr val="FFFFFF"/>
                 </a:solidFill>
               </a:rPr>
-              <a:t>Screening</a:t>
+              <a:t>Location Screening</a:t>
             </a:r>
             <a:endParaRPr sz="5200"/>
           </a:p>
@@ -3498,14 +3326,14 @@
               <a:buNone/>
             </a:pPr>
             <a:r>
-              <a:rPr lang="en-US" sz="2000" b="1" dirty="0">
+              <a:rPr sz="2000" b="1">
                 <a:solidFill>
                   <a:srgbClr val="E8A020"/>
                 </a:solidFill>
               </a:rPr>
               <a:t>-&gt;</a:t>
             </a:r>
-            <a:endParaRPr sz="2000" dirty="0"/>
+            <a:endParaRPr sz="2000"/>
           </a:p>
         </p:txBody>
       </p:sp>
@@ -3905,14 +3733,14 @@
               <a:buNone/>
             </a:pPr>
             <a:r>
-              <a:rPr lang="en-US" sz="2000" b="1" dirty="0">
+              <a:rPr sz="2000" b="1">
                 <a:solidFill>
                   <a:srgbClr val="E8A020"/>
                 </a:solidFill>
               </a:rPr>
               <a:t>-&gt;</a:t>
             </a:r>
-            <a:endParaRPr sz="2000" dirty="0"/>
+            <a:endParaRPr sz="2000"/>
           </a:p>
         </p:txBody>
       </p:sp>
@@ -4593,52 +4421,26 @@
               <a:buNone/>
             </a:pPr>
             <a:r>
-              <a:rPr sz="1100" b="1" dirty="0">
+              <a:rPr sz="1100" b="1">
                 <a:solidFill>
                   <a:srgbClr val="E8A020"/>
                 </a:solidFill>
               </a:rPr>
-              <a:t>KEY </a:t>
-            </a:r>
-            <a:r>
-              <a:rPr lang="en-US" sz="1100" b="1" dirty="0">
-                <a:solidFill>
-                  <a:srgbClr val="E8A020"/>
-                </a:solidFill>
-              </a:rPr>
-              <a:t>FINDING</a:t>
-            </a:r>
-            <a:r>
-              <a:rPr sz="1100" b="1" dirty="0">
-                <a:solidFill>
-                  <a:srgbClr val="E8A020"/>
-                </a:solidFill>
-              </a:rPr>
-              <a:t> 1</a:t>
-            </a:r>
-            <a:endParaRPr lang="en-US" sz="1100" b="1" dirty="0">
-              <a:solidFill>
-                <a:srgbClr val="E8A020"/>
-              </a:solidFill>
-            </a:endParaRPr>
+              <a:t>KEY FINDING 1</a:t>
+            </a:r>
           </a:p>
           <a:p>
             <a:pPr marL="0" indent="0">
               <a:buNone/>
             </a:pPr>
             <a:r>
-              <a:rPr lang="en-US" sz="1000" dirty="0">
+              <a:rPr sz="1000">
                 <a:solidFill>
                   <a:schemeClr val="accent6"/>
                 </a:solidFill>
               </a:rPr>
               <a:t>observed history and 2026 comparative estimate</a:t>
             </a:r>
-            <a:endParaRPr sz="1000" dirty="0">
-              <a:solidFill>
-                <a:schemeClr val="accent6"/>
-              </a:solidFill>
-            </a:endParaRPr>
           </a:p>
         </p:txBody>
       </p:sp>
@@ -4806,26 +4608,14 @@
       </p:sp>
       <p:pic>
         <p:nvPicPr>
-          <p:cNvPr id="9" name="Picture 8">
-            <a:extLst>
-              <a:ext uri="{FF2B5EF4-FFF2-40B4-BE49-F238E27FC236}">
-                <a16:creationId xmlns:a16="http://schemas.microsoft.com/office/drawing/2014/main" id="{8DB38B7C-228F-B2AA-92AC-419C3B16224E}"/>
-              </a:ext>
-            </a:extLst>
-          </p:cNvPr>
+          <p:cNvPr id="44" name="Picture 8"/>
           <p:cNvPicPr>
             <a:picLocks noChangeAspect="1"/>
           </p:cNvPicPr>
           <p:nvPr/>
         </p:nvPicPr>
         <p:blipFill>
-          <a:blip r:embed="rId3">
-            <a:extLst>
-              <a:ext uri="{28A0092B-C50C-407E-A947-70E740481C1C}">
-                <a14:useLocalDpi xmlns:a14="http://schemas.microsoft.com/office/drawing/2010/main" val="0"/>
-              </a:ext>
-            </a:extLst>
-          </a:blip>
+          <a:blip r:embed="rId3"/>
           <a:stretch>
             <a:fillRect/>
           </a:stretch>
@@ -4972,7 +4762,7 @@
           <a:bodyPr/>
           <a:lstStyle/>
           <a:p>
-            <a:endParaRPr lang="en-US" dirty="0"/>
+            <a:endParaRPr/>
           </a:p>
         </p:txBody>
       </p:sp>
@@ -5008,36 +4798,26 @@
               <a:buNone/>
             </a:pPr>
             <a:r>
-              <a:rPr sz="1100" b="1" dirty="0">
+              <a:rPr sz="1100" b="1">
                 <a:solidFill>
                   <a:srgbClr val="E8A020"/>
                 </a:solidFill>
               </a:rPr>
               <a:t>KEY FINDING 2</a:t>
             </a:r>
-            <a:endParaRPr lang="en-US" sz="1100" b="1" dirty="0">
-              <a:solidFill>
-                <a:srgbClr val="E8A020"/>
-              </a:solidFill>
-            </a:endParaRPr>
           </a:p>
           <a:p>
             <a:pPr marL="0" indent="0">
               <a:buNone/>
             </a:pPr>
             <a:r>
-              <a:rPr lang="en-US" sz="1000" dirty="0">
+              <a:rPr sz="1000">
                 <a:solidFill>
                   <a:schemeClr val="accent6"/>
                 </a:solidFill>
               </a:rPr>
               <a:t>complementary context</a:t>
             </a:r>
-            <a:endParaRPr sz="1000" dirty="0">
-              <a:solidFill>
-                <a:schemeClr val="accent6"/>
-              </a:solidFill>
-            </a:endParaRPr>
           </a:p>
         </p:txBody>
       </p:sp>
@@ -7162,36 +6942,26 @@
               <a:buNone/>
             </a:pPr>
             <a:r>
-              <a:rPr sz="1100" b="1" dirty="0">
+              <a:rPr sz="1100" b="1">
                 <a:solidFill>
                   <a:srgbClr val="E8A020"/>
                 </a:solidFill>
               </a:rPr>
               <a:t>KEY FINDING 3 — MODEL</a:t>
             </a:r>
-            <a:endParaRPr lang="en-US" sz="1100" b="1" dirty="0">
-              <a:solidFill>
-                <a:srgbClr val="E8A020"/>
-              </a:solidFill>
-            </a:endParaRPr>
           </a:p>
           <a:p>
             <a:pPr marL="0" indent="0">
               <a:buNone/>
             </a:pPr>
             <a:r>
-              <a:rPr lang="en-US" sz="1000" dirty="0">
+              <a:rPr sz="1000">
                 <a:solidFill>
                   <a:schemeClr val="accent6"/>
                 </a:solidFill>
               </a:rPr>
               <a:t>model comparison</a:t>
             </a:r>
-            <a:endParaRPr sz="1000" dirty="0">
-              <a:solidFill>
-                <a:schemeClr val="accent6"/>
-              </a:solidFill>
-            </a:endParaRPr>
           </a:p>
         </p:txBody>
       </p:sp>
@@ -7324,7 +7094,7 @@
           <a:bodyPr/>
           <a:lstStyle/>
           <a:p>
-            <a:endParaRPr dirty="0"/>
+            <a:endParaRPr/>
           </a:p>
         </p:txBody>
       </p:sp>
@@ -7509,19 +7279,19 @@
           <a:lstStyle/>
           <a:p>
             <a:r>
-              <a:rPr lang="en-US" sz="800" dirty="0"/>
+              <a:rPr sz="800"/>
               <a:t>Historical </a:t>
             </a:r>
             <a:r>
-              <a:rPr lang="en-US" sz="800" b="1" dirty="0"/>
+              <a:rPr sz="800" b="1"/>
               <a:t>recurrence</a:t>
             </a:r>
             <a:r>
-              <a:rPr lang="en-US" sz="800" dirty="0"/>
+              <a:rPr sz="800"/>
               <a:t> benchmark </a:t>
             </a:r>
             <a:r>
-              <a:rPr sz="850" dirty="0">
+              <a:rPr sz="850">
                 <a:solidFill>
                   <a:srgbClr val="1A2638"/>
                 </a:solidFill>
@@ -7529,11 +7299,11 @@
               <a:t> -&gt; </a:t>
             </a:r>
             <a:r>
-              <a:rPr lang="en-US" sz="800" b="1" dirty="0"/>
+              <a:rPr sz="800" b="1"/>
               <a:t>Nine-feature</a:t>
             </a:r>
             <a:r>
-              <a:rPr lang="en-US" sz="800" dirty="0"/>
+              <a:rPr sz="800"/>
               <a:t> Model</a:t>
             </a:r>
           </a:p>
@@ -7647,22 +7417,17 @@
               <a:buNone/>
             </a:pPr>
             <a:r>
-              <a:rPr sz="850" dirty="0">
+              <a:rPr sz="850">
                 <a:solidFill>
                   <a:srgbClr val="1A2638"/>
                 </a:solidFill>
               </a:rPr>
               <a:t>Historical recurrence baseline</a:t>
             </a:r>
-            <a:endParaRPr lang="en-US" sz="850" dirty="0">
-              <a:solidFill>
-                <a:srgbClr val="1A2638"/>
-              </a:solidFill>
-            </a:endParaRPr>
-          </a:p>
-          <a:p>
-            <a:r>
-              <a:rPr lang="en-US" sz="700" i="1" dirty="0">
+          </a:p>
+          <a:p>
+            <a:r>
+              <a:rPr sz="700" i="1">
                 <a:solidFill>
                   <a:schemeClr val="tx1">
                     <a:lumMod val="50000"/>
@@ -7780,45 +7545,21 @@
           <a:lstStyle/>
           <a:p>
             <a:r>
-              <a:rPr sz="850" dirty="0">
+              <a:rPr sz="850">
                 <a:solidFill>
                   <a:srgbClr val="1A2638"/>
                 </a:solidFill>
               </a:rPr>
-              <a:t>Nine-feature </a:t>
-            </a:r>
-            <a:r>
-              <a:rPr lang="en-US" sz="850" dirty="0">
-                <a:solidFill>
-                  <a:srgbClr val="1A2638"/>
-                </a:solidFill>
-              </a:rPr>
-              <a:t>two-stage regression</a:t>
-            </a:r>
-            <a:r>
-              <a:rPr sz="850" dirty="0">
-                <a:solidFill>
-                  <a:srgbClr val="1A2638"/>
-                </a:solidFill>
-              </a:rPr>
-              <a:t> model</a:t>
-            </a:r>
-            <a:r>
-              <a:rPr lang="en-US" sz="850" dirty="0">
-                <a:solidFill>
-                  <a:srgbClr val="1A2638"/>
-                </a:solidFill>
-              </a:rPr>
-              <a:t>:</a:t>
+              <a:t>Nine-feature two-stage regression model:</a:t>
             </a:r>
           </a:p>
           <a:p>
             <a:pPr marL="171450" indent="-171450">
-              <a:buFont typeface="Arial" panose="020B0604020202020204" pitchFamily="34" charset="0"/>
+              <a:buFont typeface="Arial"/>
               <a:buChar char="•"/>
             </a:pPr>
             <a:r>
-              <a:rPr lang="en-US" sz="700" b="1" i="1" dirty="0" err="1">
+              <a:rPr sz="700" b="1" i="1">
                 <a:solidFill>
                   <a:schemeClr val="tx1">
                     <a:lumMod val="50000"/>
@@ -7829,7 +7570,7 @@
               <a:t>HistGradientBoostingClassifier</a:t>
             </a:r>
             <a:r>
-              <a:rPr lang="en-US" sz="700" i="1" dirty="0">
+              <a:rPr sz="700" i="1">
                 <a:solidFill>
                   <a:schemeClr val="tx1">
                     <a:lumMod val="50000"/>
@@ -7842,11 +7583,11 @@
           </a:p>
           <a:p>
             <a:pPr marL="171450" indent="-171450">
-              <a:buFont typeface="Arial" panose="020B0604020202020204" pitchFamily="34" charset="0"/>
+              <a:buFont typeface="Arial"/>
               <a:buChar char="•"/>
             </a:pPr>
             <a:r>
-              <a:rPr lang="en-US" sz="700" b="1" i="1" dirty="0" err="1">
+              <a:rPr sz="700" b="1" i="1">
                 <a:solidFill>
                   <a:schemeClr val="tx1">
                     <a:lumMod val="50000"/>
@@ -7857,7 +7598,7 @@
               <a:t>HistGradientBoostingRegressor</a:t>
             </a:r>
             <a:r>
-              <a:rPr lang="en-US" sz="700" i="1" dirty="0">
+              <a:rPr sz="700" i="1">
                 <a:solidFill>
                   <a:schemeClr val="tx1">
                     <a:lumMod val="50000"/>
@@ -7870,7 +7611,7 @@
           </a:p>
           <a:p>
             <a:r>
-              <a:rPr lang="en-US" sz="700" i="1" dirty="0">
+              <a:rPr sz="700" i="1">
                 <a:solidFill>
                   <a:schemeClr val="tx1">
                     <a:lumMod val="50000"/>
@@ -7880,13 +7621,13 @@
               </a:rPr>
               <a:t>the accepted model using fire history, land cover, terrain, and climate predictors</a:t>
             </a:r>
-            <a:endParaRPr lang="en-US" sz="800" dirty="0"/>
+            <a:endParaRPr sz="800"/>
           </a:p>
           <a:p>
             <a:pPr marL="0" indent="0">
               <a:buNone/>
             </a:pPr>
-            <a:endParaRPr sz="850" b="1" dirty="0"/>
+            <a:endParaRPr sz="850" b="1"/>
           </a:p>
         </p:txBody>
       </p:sp>
@@ -7998,38 +7739,14 @@
               <a:buNone/>
             </a:pPr>
             <a:r>
-              <a:rPr sz="850" dirty="0">
+              <a:rPr sz="850">
                 <a:solidFill>
                   <a:srgbClr val="1A2638"/>
                 </a:solidFill>
               </a:rPr>
-              <a:t>MAE: 0.029</a:t>
-            </a:r>
-            <a:r>
-              <a:rPr lang="en-US" sz="850" dirty="0">
-                <a:solidFill>
-                  <a:srgbClr val="1A2638"/>
-                </a:solidFill>
-              </a:rPr>
-              <a:t>2</a:t>
-            </a:r>
-            <a:r>
-              <a:rPr sz="850" dirty="0">
-                <a:solidFill>
-                  <a:srgbClr val="1A2638"/>
-                </a:solidFill>
-              </a:rPr>
-              <a:t>  -&gt;  0.02</a:t>
-            </a:r>
-            <a:r>
-              <a:rPr lang="en-US" sz="850" dirty="0">
-                <a:solidFill>
-                  <a:srgbClr val="1A2638"/>
-                </a:solidFill>
-              </a:rPr>
-              <a:t>09</a:t>
-            </a:r>
-            <a:endParaRPr sz="850" dirty="0"/>
+              <a:t>MAE: 0.0292  -&gt;  0.0209</a:t>
+            </a:r>
+            <a:endParaRPr sz="850"/>
           </a:p>
         </p:txBody>
       </p:sp>
@@ -8141,38 +7858,14 @@
               <a:buNone/>
             </a:pPr>
             <a:r>
-              <a:rPr sz="850" dirty="0">
+              <a:rPr sz="850">
                 <a:solidFill>
                   <a:srgbClr val="1A2638"/>
                 </a:solidFill>
               </a:rPr>
-              <a:t>RMSE: 0.11</a:t>
-            </a:r>
-            <a:r>
-              <a:rPr lang="en-US" sz="850" dirty="0">
-                <a:solidFill>
-                  <a:srgbClr val="1A2638"/>
-                </a:solidFill>
-              </a:rPr>
-              <a:t>06</a:t>
-            </a:r>
-            <a:r>
-              <a:rPr sz="850" dirty="0">
-                <a:solidFill>
-                  <a:srgbClr val="1A2638"/>
-                </a:solidFill>
-              </a:rPr>
-              <a:t>  -&gt;  0.111</a:t>
-            </a:r>
-            <a:r>
-              <a:rPr lang="en-US" sz="850" dirty="0">
-                <a:solidFill>
-                  <a:srgbClr val="1A2638"/>
-                </a:solidFill>
-              </a:rPr>
-              <a:t>0</a:t>
-            </a:r>
-            <a:endParaRPr sz="850" dirty="0"/>
+              <a:t>RMSE: 0.1106  -&gt;  0.1110</a:t>
+            </a:r>
+            <a:endParaRPr sz="850"/>
           </a:p>
         </p:txBody>
       </p:sp>
@@ -8284,41 +7977,17 @@
               <a:buNone/>
             </a:pPr>
             <a:r>
-              <a:rPr sz="850" dirty="0">
+              <a:rPr sz="850">
                 <a:solidFill>
                   <a:srgbClr val="1A2638"/>
                 </a:solidFill>
               </a:rPr>
-              <a:t>Capture@20%: </a:t>
-            </a:r>
-            <a:r>
-              <a:rPr lang="en-US" sz="850" dirty="0">
-                <a:solidFill>
-                  <a:srgbClr val="1A2638"/>
-                </a:solidFill>
-              </a:rPr>
-              <a:t>40.2%</a:t>
-            </a:r>
-            <a:r>
-              <a:rPr sz="850" dirty="0">
-                <a:solidFill>
-                  <a:srgbClr val="1A2638"/>
-                </a:solidFill>
-              </a:rPr>
-              <a:t>  -&gt;  </a:t>
-            </a:r>
-            <a:r>
-              <a:rPr lang="en-US" sz="850" dirty="0">
-                <a:solidFill>
-                  <a:srgbClr val="1A2638"/>
-                </a:solidFill>
-              </a:rPr>
-              <a:t>57.2%</a:t>
-            </a:r>
-          </a:p>
-          <a:p>
-            <a:r>
-              <a:rPr lang="en-US" sz="700" i="1" dirty="0">
+              <a:t>Capture@20%: 40.2%  -&gt;  57.2%</a:t>
+            </a:r>
+          </a:p>
+          <a:p>
+            <a:r>
+              <a:rPr sz="700" i="1">
                 <a:solidFill>
                   <a:schemeClr val="tx1">
                     <a:lumMod val="50000"/>
@@ -8436,7 +8105,7 @@
           <a:lstStyle/>
           <a:p>
             <a:r>
-              <a:rPr lang="en-US" sz="800" dirty="0"/>
+              <a:rPr sz="800"/>
               <a:t>Final test: predictor years T=2022–2024; outcomes T+1=2023–2025</a:t>
             </a:r>
           </a:p>
@@ -9033,14 +8702,14 @@
               <a:buNone/>
             </a:pPr>
             <a:r>
-              <a:rPr sz="750" b="1" dirty="0">
+              <a:rPr sz="750" b="1">
                 <a:solidFill>
                   <a:srgbClr val="E8A020"/>
                 </a:solidFill>
               </a:rPr>
               <a:t>It is a ranking diagnostic, not a buyer threshold.</a:t>
             </a:r>
-            <a:endParaRPr sz="750" dirty="0"/>
+            <a:endParaRPr sz="750"/>
           </a:p>
         </p:txBody>
       </p:sp>
@@ -10022,14 +9691,14 @@
               <a:buNone/>
             </a:pPr>
             <a:r>
-              <a:rPr lang="en-US" sz="2000" b="1" dirty="0">
+              <a:rPr sz="2000" b="1">
                 <a:solidFill>
                   <a:srgbClr val="E8A020"/>
                 </a:solidFill>
               </a:rPr>
               <a:t>-&gt;</a:t>
             </a:r>
-            <a:endParaRPr sz="2000" dirty="0"/>
+            <a:endParaRPr sz="2000"/>
           </a:p>
         </p:txBody>
       </p:sp>
@@ -10429,14 +10098,14 @@
               <a:buNone/>
             </a:pPr>
             <a:r>
-              <a:rPr lang="en-US" sz="2000" b="1" dirty="0">
+              <a:rPr sz="2000" b="1">
                 <a:solidFill>
                   <a:srgbClr val="E8A020"/>
                 </a:solidFill>
               </a:rPr>
               <a:t>-&gt;</a:t>
             </a:r>
-            <a:endParaRPr sz="2000" dirty="0"/>
+            <a:endParaRPr sz="2000"/>
           </a:p>
         </p:txBody>
       </p:sp>
@@ -10457,7 +10126,7 @@
         <p:spPr>
           <a:xfrm>
             <a:off x="6345936" y="1371600"/>
-            <a:ext cx="2651760" cy="2834640"/>
+            <a:ext cx="2514600" cy="2834640"/>
           </a:xfrm>
           <a:prstGeom prst="rect">
             <a:avLst/>
@@ -10497,7 +10166,7 @@
         <p:spPr>
           <a:xfrm>
             <a:off x="6345936" y="1371600"/>
-            <a:ext cx="2651760" cy="384048"/>
+            <a:ext cx="2514600" cy="384048"/>
           </a:xfrm>
           <a:prstGeom prst="rect">
             <a:avLst/>
@@ -10616,7 +10285,7 @@
         <p:spPr>
           <a:xfrm>
             <a:off x="6437376" y="2048256"/>
-            <a:ext cx="2468880" cy="502920"/>
+            <a:ext cx="2341179" cy="502920"/>
           </a:xfrm>
           <a:prstGeom prst="rect">
             <a:avLst/>
@@ -10659,7 +10328,7 @@
         <p:spPr>
           <a:xfrm>
             <a:off x="6437376" y="2578608"/>
-            <a:ext cx="2468880" cy="502920"/>
+            <a:ext cx="2341179" cy="502920"/>
           </a:xfrm>
           <a:prstGeom prst="rect">
             <a:avLst/>
@@ -13766,14 +13435,14 @@
               <a:buNone/>
             </a:pPr>
             <a:r>
-              <a:rPr lang="en-US" sz="2000" b="1" dirty="0">
+              <a:rPr sz="2000" b="1">
                 <a:solidFill>
                   <a:srgbClr val="E8A020"/>
                 </a:solidFill>
               </a:rPr>
               <a:t>-&gt;</a:t>
             </a:r>
-            <a:endParaRPr sz="2000" dirty="0"/>
+            <a:endParaRPr sz="2000"/>
           </a:p>
         </p:txBody>
       </p:sp>
@@ -14173,14 +13842,14 @@
               <a:buNone/>
             </a:pPr>
             <a:r>
-              <a:rPr lang="en-US" sz="2000" b="1" dirty="0">
+              <a:rPr sz="2000" b="1">
                 <a:solidFill>
                   <a:srgbClr val="E8A020"/>
                 </a:solidFill>
               </a:rPr>
               <a:t>-&gt;</a:t>
             </a:r>
-            <a:endParaRPr sz="2000" dirty="0"/>
+            <a:endParaRPr sz="2000"/>
           </a:p>
         </p:txBody>
       </p:sp>
@@ -14201,7 +13870,7 @@
         <p:spPr>
           <a:xfrm>
             <a:off x="6345936" y="1371600"/>
-            <a:ext cx="2651760" cy="2834640"/>
+            <a:ext cx="2514600" cy="2834640"/>
           </a:xfrm>
           <a:prstGeom prst="rect">
             <a:avLst/>
@@ -14241,7 +13910,7 @@
         <p:spPr>
           <a:xfrm>
             <a:off x="6345936" y="1371600"/>
-            <a:ext cx="2651760" cy="384048"/>
+            <a:ext cx="2523744" cy="384048"/>
           </a:xfrm>
           <a:prstGeom prst="rect">
             <a:avLst/>
@@ -14360,7 +14029,7 @@
         <p:spPr>
           <a:xfrm>
             <a:off x="6437376" y="2048256"/>
-            <a:ext cx="2468880" cy="502920"/>
+            <a:ext cx="2340864" cy="502920"/>
           </a:xfrm>
           <a:prstGeom prst="rect">
             <a:avLst/>
@@ -14375,14 +14044,14 @@
               <a:buNone/>
             </a:pPr>
             <a:r>
-              <a:rPr sz="850">
+              <a:rPr sz="850" dirty="0">
                 <a:solidFill>
                   <a:srgbClr val="1A2638"/>
                 </a:solidFill>
               </a:rPr>
               <a:t>When new completed-year data and the 2026 outcome are available, rerun the fixed workflow and evaluate the 2026 estimate.</a:t>
             </a:r>
-            <a:endParaRPr sz="850"/>
+            <a:endParaRPr sz="850" dirty="0"/>
           </a:p>
         </p:txBody>
       </p:sp>
@@ -14403,7 +14072,7 @@
         <p:spPr>
           <a:xfrm>
             <a:off x="6437376" y="2578608"/>
-            <a:ext cx="2468880" cy="502920"/>
+            <a:ext cx="2340864" cy="502920"/>
           </a:xfrm>
           <a:prstGeom prst="rect">
             <a:avLst/>

</xml_diff>

<commit_message>
Clarify model development, evaluation, and operational refit stages.
</commit_message>
<xml_diff>
--- a/reports/presentation/wildfire_exposure_screening_capstone_final.pptx
+++ b/reports/presentation/wildfire_exposure_screening_capstone_final.pptx
@@ -2,21 +2,21 @@
 <file path=ppt/presentation.xml><?xml version="1.0" encoding="utf-8"?>
 <p:presentation xmlns:p="http://schemas.openxmlformats.org/presentationml/2006/main">
   <p:sldMasterIdLst>
-    <p:sldMasterId xmlns:r="http://schemas.openxmlformats.org/officeDocument/2006/relationships" id="2147483648" r:id="R6a850674f28b41bd"/>
+    <p:sldMasterId xmlns:r="http://schemas.openxmlformats.org/officeDocument/2006/relationships" id="2147483648" r:id="Re4bbadf8fee84872"/>
   </p:sldMasterIdLst>
   <p:notesMasterIdLst>
-    <p:notesMasterId xmlns:r="http://schemas.openxmlformats.org/officeDocument/2006/relationships" r:id="R828ffdde7a3f4a46"/>
+    <p:notesMasterId xmlns:r="http://schemas.openxmlformats.org/officeDocument/2006/relationships" r:id="R0aff1b2607dd4085"/>
   </p:notesMasterIdLst>
   <p:sldIdLst>
-    <p:sldId xmlns:r="http://schemas.openxmlformats.org/officeDocument/2006/relationships" id="256" r:id="Rb6160a0e36e74486"/>
-    <p:sldId xmlns:r="http://schemas.openxmlformats.org/officeDocument/2006/relationships" id="257" r:id="Rd7bf4c9e5eba43e8"/>
-    <p:sldId xmlns:r="http://schemas.openxmlformats.org/officeDocument/2006/relationships" id="258" r:id="R641a2101a7af434f"/>
-    <p:sldId xmlns:r="http://schemas.openxmlformats.org/officeDocument/2006/relationships" id="259" r:id="R9d612d399ebd4651"/>
-    <p:sldId xmlns:r="http://schemas.openxmlformats.org/officeDocument/2006/relationships" id="260" r:id="R8ca9ab63b6d242c4"/>
-    <p:sldId xmlns:r="http://schemas.openxmlformats.org/officeDocument/2006/relationships" id="261" r:id="Ra5af360aade74f54"/>
-    <p:sldId xmlns:r="http://schemas.openxmlformats.org/officeDocument/2006/relationships" id="262" r:id="Rb7c59d1378024732"/>
-    <p:sldId xmlns:r="http://schemas.openxmlformats.org/officeDocument/2006/relationships" id="263" r:id="R5350da04be4f4385"/>
-    <p:sldId xmlns:r="http://schemas.openxmlformats.org/officeDocument/2006/relationships" id="264" r:id="Re4377d5b80564fa6"/>
+    <p:sldId xmlns:r="http://schemas.openxmlformats.org/officeDocument/2006/relationships" id="256" r:id="Rcad490e820d441b8"/>
+    <p:sldId xmlns:r="http://schemas.openxmlformats.org/officeDocument/2006/relationships" id="257" r:id="R088d2814a5b84d32"/>
+    <p:sldId xmlns:r="http://schemas.openxmlformats.org/officeDocument/2006/relationships" id="258" r:id="R2224af1b8499482a"/>
+    <p:sldId xmlns:r="http://schemas.openxmlformats.org/officeDocument/2006/relationships" id="259" r:id="Rc928aa4d4918417b"/>
+    <p:sldId xmlns:r="http://schemas.openxmlformats.org/officeDocument/2006/relationships" id="260" r:id="R70e430d44022412e"/>
+    <p:sldId xmlns:r="http://schemas.openxmlformats.org/officeDocument/2006/relationships" id="261" r:id="R0d3bee12749b4e10"/>
+    <p:sldId xmlns:r="http://schemas.openxmlformats.org/officeDocument/2006/relationships" id="262" r:id="R884088e941bb45aa"/>
+    <p:sldId xmlns:r="http://schemas.openxmlformats.org/officeDocument/2006/relationships" id="263" r:id="R51923257f72c4092"/>
+    <p:sldId xmlns:r="http://schemas.openxmlformats.org/officeDocument/2006/relationships" id="264" r:id="R5be5145a01b44216"/>
   </p:sldIdLst>
   <p:sldSz cx="9144000" cy="5143500"/>
   <p:notesSz cx="6858000" cy="9144000"/>
@@ -626,16 +626,21 @@
           </a:p>
           <a:p xmlns:a="http://schemas.openxmlformats.org/drawingml/2006/main">
             <a:r>
+              <a:t>The 2000–2025 range shown on this slide is ICNF source archive coverage. It is not one training or evaluation period. Earlier ICNF years supply the ten-year pre-T fire-history windows, while later years also supply observed T+1 outcomes.</a:t>
+            </a:r>
+            <a:endParaRPr/>
+          </a:p>
+          <a:p xmlns:a="http://schemas.openxmlformats.org/drawingml/2006/main">
+            <a:r>
+              <a:rPr b="1"/>
               <a:t>CLC land cover and Copernicus DEM provide landscape and terrain context. ERA5-Land provides warm-season temperature, precipitation, and shallow soil-water conditions from the predictor year only.</a:t>
             </a:r>
             <a:endParaRPr/>
           </a:p>
           <a:p xmlns:a="http://schemas.openxmlformats.org/drawingml/2006/main">
             <a:r>
-              <a:rPr b="1"/>
               <a:t>The 2 km area is not a second grid. It is an outward context buffer around each 1 km cell, used to measure nearby forest/shrub, slope, and historical fire recurrence.”</a:t>
             </a:r>
-            <a:endParaRPr/>
           </a:p>
           <a:p xmlns:a="http://schemas.openxmlformats.org/drawingml/2006/main">
             <a:r>
@@ -644,7 +649,7 @@
           </a:p>
           <a:p xmlns:a="http://schemas.openxmlformats.org/drawingml/2006/main">
             <a:r>
-              <a:t>Transition: “Next, I will show how these historical rows were separated for training, validation, final temporal evaluation, and the current 2026 estimate.”</a:t>
+              <a:t>Transition: “Next, I will show the exact training, validation, final-evaluation, refit, and current-estimate periods.”</a:t>
             </a:r>
           </a:p>
           <a:p xmlns:a="http://schemas.openxmlformats.org/drawingml/2006/main">
@@ -659,7 +664,7 @@
           </a:p>
           <a:p xmlns:a="http://schemas.openxmlformats.org/drawingml/2006/main">
             <a:r>
-              <a:t>docs/data_dictionary.md; reports/validation/canonical_full_scope_readiness.md</a:t>
+              <a:t>docs/data_dictionary.md; docs/source_plan.md</a:t>
             </a:r>
           </a:p>
         </p:txBody>
@@ -730,7 +735,7 @@
           <a:p xmlns:a="http://schemas.openxmlformats.org/drawingml/2006/main">
             <a:r>
               <a:rPr b="1"/>
-              <a:t>Main message: Historical data are separated in time before the current 2026 estimate is produced.</a:t>
+              <a:t>Main message: Every model period uses the same rule: predictors from year T are compared with the observed burned-share outcome in T+1.</a:t>
             </a:r>
             <a:endParaRPr/>
           </a:p>
@@ -748,24 +753,24 @@
           </a:p>
           <a:p xmlns:a="http://schemas.openxmlformats.org/drawingml/2006/main">
             <a:r>
-              <a:t>“Each analytical row is one mainland Portugal 1 km cell in predictor year T. Nine predictors describe earlier fire recurrence, land cover, terrain, and June-to-September climate. The target is the proportion of that cell’s land area that burned in T+1.</a:t>
-            </a:r>
-          </a:p>
-          <a:p xmlns:a="http://schemas.openxmlformats.org/drawingml/2006/main">
-            <a:r>
-              <a:t>Candidate models were fitted on T=2010–2019 and selected using validation years T=2020–2021. After the specification was frozen, it was evaluated once on T=2022–2024; those results were not used to tune the model.</a:t>
-            </a:r>
-          </a:p>
-          <a:p xmlns:a="http://schemas.openxmlformats.org/drawingml/2006/main">
-            <a:r>
-              <a:t>The selected specification was then refitted on all completed labelled rows through T=2024 and applied to T=2025 predictors to estimate 2026. The 2026 layer is target-free and can be evaluated only after ICNF publishes the observed 2026 burned areas.</a:t>
+              <a:t>“The date ranges have different roles and do not overlap during model selection.</a:t>
+            </a:r>
+          </a:p>
+          <a:p xmlns:a="http://schemas.openxmlformats.org/drawingml/2006/main">
+            <a:r>
+              <a:t>Model fitting uses predictor years T=2010–2019 and observed outcomes 2011–2020. Development validation uses T=2020–2021 and outcomes 2021–2022 to select the specification. The frozen specification is then evaluated once using T=2022–2024 and outcomes 2023–2025. Those final-evaluation results do not tune the model.</a:t>
+            </a:r>
+          </a:p>
+          <a:p xmlns:a="http://schemas.openxmlformats.org/drawingml/2006/main">
+            <a:r>
+              <a:t>For the operational 2026 estimate, the selected specification is refitted using all labelled predictor years T=2010–2024, whose outcomes cover 2011–2025. It is then applied to T=2025 predictors to estimate 2026. No observed 2026 outcome is available or used.</a:t>
             </a:r>
             <a:endParaRPr/>
           </a:p>
           <a:p xmlns:a="http://schemas.openxmlformats.org/drawingml/2006/main">
             <a:r>
               <a:rPr b="1"/>
-              <a:t>The temporal safeguard is simple: information from T+1 is used only as a historical target, never as a predictor.”</a:t>
+              <a:t>The temporal safeguard is that T+1 information is always a historical target, never a predictor.”</a:t>
             </a:r>
             <a:endParaRPr/>
           </a:p>
@@ -776,7 +781,7 @@
           </a:p>
           <a:p xmlns:a="http://schemas.openxmlformats.org/drawingml/2006/main">
             <a:r>
-              <a:t>Transition: “With the temporal separation clear, the next slides present the geographical evidence and model results.”</a:t>
+              <a:t>Transition: “The next slides separate the descriptive historical screen, the official reference layer, and the model estimate.”</a:t>
             </a:r>
           </a:p>
           <a:p xmlns:a="http://schemas.openxmlformats.org/drawingml/2006/main">
@@ -862,69 +867,74 @@
           <a:p xmlns:a="http://schemas.openxmlformats.org/drawingml/2006/main">
             <a:r>
               <a:rPr b="1"/>
-              <a:t>Main message:</a:t>
-            </a:r>
-            <a:r>
-              <a:t> Wildfire exposure patterns vary geographically, so a national location search can be narrowed using comparative evidence.</a:t>
+              <a:t>Main message: Wildfire exposure patterns vary geographically, so a national location search can be narrowed using comparative evidence.</a:t>
             </a:r>
           </a:p>
           <a:p xmlns:a="http://schemas.openxmlformats.org/drawingml/2006/main">
             <a:r>
               <a:t>These layers provide different types of evidence and should not be added together or interpreted as one score. The comparison helps identify broad areas for further investigation; it does not certify a location.</a:t>
             </a:r>
-            <a:br/>
-            <a:br/>
+            <a:endParaRPr/>
+          </a:p>
+          <a:p xmlns:a="http://schemas.openxmlformats.org/drawingml/2006/main">
+            <a:r>
+              <a:t/>
+            </a:r>
+          </a:p>
+          <a:p xmlns:a="http://schemas.openxmlformats.org/drawingml/2006/main">
+            <a:r>
+              <a:t>What to say:</a:t>
+            </a:r>
+          </a:p>
+          <a:p xmlns:a="http://schemas.openxmlformats.org/drawingml/2006/main">
+            <a:r>
+              <a:t>“This slide shows three different views of the same national geography.</a:t>
+            </a:r>
+          </a:p>
+          <a:p xmlns:a="http://schemas.openxmlformats.org/drawingml/2006/main">
+            <a:r>
+              <a:t>The first map shows observed historical recurrence: how many distinct years had burned-area evidence between 2016 and 2025 within the 2 km context around each 1 km cell. This 2016–2025 window is a separate descriptive screening period, not the model training period.</a:t>
+            </a:r>
+          </a:p>
+          <a:p xmlns:a="http://schemas.openxmlformats.org/drawingml/2006/main">
+            <a:r>
+              <a:t>The second map is the official ICNF structural-hazard classification. It describes persistent landscape conditions rather than what burned in one particular year.</a:t>
+            </a:r>
+          </a:p>
+          <a:p xmlns:a="http://schemas.openxmlformats.org/drawingml/2006/main">
+            <a:r>
+              <a:t>The third map is the project’s target-free 2026 comparative estimate. It uses T=2025 predictor inputs and does not use an observed 2026 outcome.</a:t>
+            </a:r>
+            <a:endParaRPr/>
+          </a:p>
+          <a:p xmlns:a="http://schemas.openxmlformats.org/drawingml/2006/main">
             <a:r>
               <a:rPr b="1"/>
-              <a:t>What to say:</a:t>
+              <a:t>These maps should not be added together into one score. They provide different evidence for comparing broad areas and deciding where additional research is worthwhile.”</a:t>
+            </a:r>
+          </a:p>
+          <a:p xmlns:a="http://schemas.openxmlformats.org/drawingml/2006/main">
+            <a:r>
+              <a:t/>
             </a:r>
             <a:endParaRPr/>
           </a:p>
           <a:p xmlns:a="http://schemas.openxmlformats.org/drawingml/2006/main">
             <a:r>
-              <a:t>“This slide shows three different views of the same national geography.</a:t>
-            </a:r>
-          </a:p>
-          <a:p xmlns:a="http://schemas.openxmlformats.org/drawingml/2006/main">
-            <a:r>
-              <a:t>The first map shows observed historical recurrence: how many distinct years had burned-area evidence between 2016 and 2025 within the 2 km context around each 1 km cell.</a:t>
-            </a:r>
-          </a:p>
-          <a:p xmlns:a="http://schemas.openxmlformats.org/drawingml/2006/main">
-            <a:r>
-              <a:t>The second map is the ICNF and official Portuguese government map showing where the landscape has more or less underlying potential to support severe wildfire conditions. It describes persistent landscape hazard conditions rather than what burned in one particular year.</a:t>
-            </a:r>
-          </a:p>
-          <a:p xmlns:a="http://schemas.openxmlformats.org/drawingml/2006/main">
-            <a:r>
-              <a:t>The third map is the project’s 2026 comparative estimate. It uses information available through 2025 to rank 1 km cells by estimated next-year burned share.</a:t>
-            </a:r>
-          </a:p>
-          <a:p xmlns:a="http://schemas.openxmlformats.org/drawingml/2006/main">
-            <a:r>
-              <a:t>These maps should not be added together into one score. They provide different evidence for comparing broad areas and deciding where additional research is worthwhile.”</a:t>
-            </a:r>
-          </a:p>
-          <a:p xmlns:a="http://schemas.openxmlformats.org/drawingml/2006/main">
-            <a:endParaRPr/>
-          </a:p>
-          <a:p xmlns:a="http://schemas.openxmlformats.org/drawingml/2006/main">
-            <a:r>
-              <a:rPr b="1"/>
-              <a:t>Transition:</a:t>
-            </a:r>
-            <a:r>
-              <a:t> “Because historical recurrence and official structural hazard measure different things, the next question is why it is useful to compare them.”</a:t>
-            </a:r>
-          </a:p>
-          <a:p xmlns:a="http://schemas.openxmlformats.org/drawingml/2006/main">
-            <a:endParaRPr/>
+              <a:t>Transition: “Because historical recurrence and official structural hazard measure different things, the next question is why it is useful to compare them.”</a:t>
+            </a:r>
+          </a:p>
+          <a:p xmlns:a="http://schemas.openxmlformats.org/drawingml/2006/main">
+            <a:r>
+              <a:t/>
+            </a:r>
           </a:p>
           <a:p xmlns:a="http://schemas.openxmlformats.org/drawingml/2006/main">
             <a:r>
               <a:t>[Sources]</a:t>
             </a:r>
-            <a:br/>
+          </a:p>
+          <a:p xmlns:a="http://schemas.openxmlformats.org/drawingml/2006/main">
             <a:r>
               <a:t>reports/figures/historical_wildfire_exposure_screening_mainland_portugal.png; reports/validation/historical_exposure_screening_and_icnf_comparison.md; qgis/README.md; reports/validation/operational_forecast_2026_validation.md</a:t>
             </a:r>
@@ -1125,13 +1135,13 @@
           <a:p xmlns:a="http://schemas.openxmlformats.org/drawingml/2006/main">
             <a:r>
               <a:rPr b="1"/>
-              <a:t>Main message:</a:t>
-            </a:r>
-            <a:r>
-              <a:t> The nine-feature two-stage regression improves average comparative error and burned-share ranking over historical recurrence alone, while extreme fire outcomes remain difficult.</a:t>
-            </a:r>
-          </a:p>
-          <a:p xmlns:a="http://schemas.openxmlformats.org/drawingml/2006/main">
+              <a:t>Main message: The nine-feature two-stage regression improves average comparative error and burned-share ranking over historical recurrence alone, while extreme fire outcomes remain difficult.</a:t>
+            </a:r>
+          </a:p>
+          <a:p xmlns:a="http://schemas.openxmlformats.org/drawingml/2006/main">
+            <a:r>
+              <a:t/>
+            </a:r>
             <a:endParaRPr b="1"/>
           </a:p>
           <a:p xmlns:a="http://schemas.openxmlformats.org/drawingml/2006/main">
@@ -1139,161 +1149,71 @@
               <a:rPr b="1"/>
               <a:t>What to say:</a:t>
             </a:r>
-            <a:br/>
-            <a:r>
-              <a:t>“This slide compares two approaches using the held-out final period: predictor years </a:t>
-            </a:r>
+          </a:p>
+          <a:p xmlns:a="http://schemas.openxmlformats.org/drawingml/2006/main">
+            <a:r>
+              <a:t>“This slide compares two approaches using the final temporal evaluation: predictor years T=2022–2024 and observed outcomes 2023–2025.</a:t>
+            </a:r>
+          </a:p>
+          <a:p xmlns:a="http://schemas.openxmlformats.org/drawingml/2006/main">
+            <a:r>
+              <a:t>The historical-recurrence baseline is a transparent project benchmark. It groups training records by the number of previously burned years in the 2 km context and uses the training-period average next-year burned share for each group. It is an empirical project benchmark, not a library model.</a:t>
+            </a:r>
+          </a:p>
+          <a:p xmlns:a="http://schemas.openxmlformats.org/drawingml/2006/main">
+            <a:r>
+              <a:t>The nine-feature model uses two HistGradientBoosting components. The first estimates whether burning occurs in a cell. The second estimates the positive burned share when burning occurs. Their outputs are combined into one continuous estimated burned share.</a:t>
+            </a:r>
+          </a:p>
+          <a:p xmlns:a="http://schemas.openxmlformats.org/drawingml/2006/main">
+            <a:r>
+              <a:t>In the final temporal evaluation, the model lowers MAE from 0.0292 to 0.0209. RMSE is almost unchanged but slightly higher, from 0.1106 to 0.1110, showing that larger and more extreme outcomes remain difficult.”</a:t>
+            </a:r>
+            <a:endParaRPr/>
+          </a:p>
+          <a:p xmlns:a="http://schemas.openxmlformats.org/drawingml/2006/main">
             <a:r>
               <a:rPr b="1"/>
-              <a:t>2022 - 2024</a:t>
-            </a:r>
-            <a:r>
-              <a:t> and observed outcomes </a:t>
-            </a:r>
+              <a:t/>
+            </a:r>
+          </a:p>
+          <a:p xmlns:a="http://schemas.openxmlformats.org/drawingml/2006/main">
+            <a:r>
+              <a:t>Capture@20% checks the ranking retrospectively. For each pair—T=2022 → outcome 2023, T=2023 → outcome 2024, and T=2024 → outcome 2025—the model ranks cells using T-only predictors. We then measure how much of the observed burned-share mass occurred within the highest-scored 20% of cells.</a:t>
+            </a:r>
+          </a:p>
+          <a:p xmlns:a="http://schemas.openxmlformats.org/drawingml/2006/main">
+            <a:r>
+              <a:t>Across this final evaluation, the historical baseline captured 40.2% of observed burned-share mass in its top-ranked 20%; the nine-feature model captured 57.2%. This does not mean that 20% of the land burned. It is a ranking diagnostic, not a buyer threshold or a property-level forecast.</a:t>
+            </a:r>
+          </a:p>
+          <a:p xmlns:a="http://schemas.openxmlformats.org/drawingml/2006/main">
+            <a:r>
+              <a:t/>
+            </a:r>
+          </a:p>
+          <a:p xmlns:a="http://schemas.openxmlformats.org/drawingml/2006/main">
+            <a:r>
+              <a:t>Transition: “The practical question is how this comparative estimate can help organise broad-area research.”</a:t>
+            </a:r>
+            <a:endParaRPr/>
+          </a:p>
+          <a:p xmlns:a="http://schemas.openxmlformats.org/drawingml/2006/main">
             <a:r>
               <a:rPr b="1"/>
-              <a:t>2023 - 2025</a:t>
-            </a:r>
-            <a:r>
-              <a:t>.</a:t>
-            </a:r>
-          </a:p>
-          <a:p xmlns:a="http://schemas.openxmlformats.org/drawingml/2006/main">
-            <a:r>
-              <a:t>The historical-recurrence baseline is a transparent project benchmark. It groups training records by the number of previously burned years in the 2 km context and uses the training-period average next-year burned share for each group. It is an empirical project benchmark, not a library model.</a:t>
-            </a:r>
-          </a:p>
-          <a:p xmlns:a="http://schemas.openxmlformats.org/drawingml/2006/main">
-            <a:r>
-              <a:t>The nine-feature Model V2 uses two HistGradientBoosting components. The first estimates whether burning is likely in a cell. The second estimates how much of the cell’s land area may burn when burning occurs. These two parts are combined into one continuous estimated burned share.</a:t>
-            </a:r>
-          </a:p>
-          <a:p xmlns:a="http://schemas.openxmlformats.org/drawingml/2006/main">
-            <a:r>
-              <a:t>On the final test, Model V2 lowers MAE from </a:t>
-            </a:r>
+              <a:t/>
+            </a:r>
+          </a:p>
+          <a:p xmlns:a="http://schemas.openxmlformats.org/drawingml/2006/main">
+            <a:r>
+              <a:t>[Sources]</a:t>
+            </a:r>
+            <a:endParaRPr b="1"/>
+          </a:p>
+          <a:p xmlns:a="http://schemas.openxmlformats.org/drawingml/2006/main">
             <a:r>
               <a:rPr b="1"/>
-              <a:t>0.0292 to 0.0209</a:t>
-            </a:r>
-            <a:r>
-              <a:t>. RMSE is almost unchanged but slightly higher, from </a:t>
-            </a:r>
-            <a:r>
-              <a:rPr b="1"/>
-              <a:t>0.1106 to 0.1110</a:t>
-            </a:r>
-            <a:r>
-              <a:t>, showing that larger and more extreme fire outcomes remain difficult.”</a:t>
-            </a:r>
-          </a:p>
-          <a:p xmlns:a="http://schemas.openxmlformats.org/drawingml/2006/main">
-            <a:endParaRPr/>
-          </a:p>
-          <a:p xmlns:a="http://schemas.openxmlformats.org/drawingml/2006/main">
-            <a:r>
-              <a:rPr b="1"/>
-              <a:t>Capture@20% is a validation test of the ranking.</a:t>
-            </a:r>
-            <a:r>
-              <a:t> For each predictor year, the model ranks cells using information from year </a:t>
-            </a:r>
-            <a:r>
-              <a:rPr b="1"/>
-              <a:t>T</a:t>
-            </a:r>
-            <a:r>
-              <a:t> and estimates burned share for </a:t>
-            </a:r>
-            <a:r>
-              <a:rPr b="1"/>
-              <a:t>T+1</a:t>
-            </a:r>
-            <a:r>
-              <a:t>. For example, for </a:t>
-            </a:r>
-            <a:r>
-              <a:rPr b="1"/>
-              <a:t>2024 -&gt; 2025</a:t>
-            </a:r>
-            <a:r>
-              <a:t>, it ranks cells using 2024 predictor data and is later checked against observed ICNF burned areas from 2025.</a:t>
-            </a:r>
-          </a:p>
-          <a:p xmlns:a="http://schemas.openxmlformats.org/drawingml/2006/main">
-            <a:r>
-              <a:t>The final evaluation covers </a:t>
-            </a:r>
-            <a:r>
-              <a:rPr b="1"/>
-              <a:t>2022 -&gt; 2023, 2023 -&gt; 2024, and 2024 -&gt; 2025</a:t>
-            </a:r>
-            <a:r>
-              <a:t>. We select the highest-scored 20% of cells and measure how much of the total observed burned-share mass occurred within those cells.</a:t>
-            </a:r>
-          </a:p>
-          <a:p xmlns:a="http://schemas.openxmlformats.org/drawingml/2006/main">
-            <a:r>
-              <a:t>Across the final test, the historical baseline captured </a:t>
-            </a:r>
-            <a:r>
-              <a:rPr b="1"/>
-              <a:t>40.2%</a:t>
-            </a:r>
-            <a:r>
-              <a:t> of observed burned-share mass in its top-ranked 20% of cells. Model V2 captured </a:t>
-            </a:r>
-            <a:r>
-              <a:rPr b="1"/>
-              <a:t>57.2%</a:t>
-            </a:r>
-            <a:r>
-              <a:t>.</a:t>
-            </a:r>
-          </a:p>
-          <a:p xmlns:a="http://schemas.openxmlformats.org/drawingml/2006/main">
-            <a:r>
-              <a:t>This does not mean that 20% of the land burned. It is a retrospective ranking diagnostic, not a buyer threshold or a property-level forecast. The same logic could later be applied to </a:t>
-            </a:r>
-            <a:r>
-              <a:rPr b="1"/>
-              <a:t>2035 -&gt; 2036</a:t>
-            </a:r>
-            <a:r>
-              <a:t>, but only after the 2036 outcome data become available.”</a:t>
-            </a:r>
-          </a:p>
-          <a:p xmlns:a="http://schemas.openxmlformats.org/drawingml/2006/main">
-            <a:endParaRPr/>
-          </a:p>
-          <a:p xmlns:a="http://schemas.openxmlformats.org/drawingml/2006/main">
-            <a:r>
-              <a:rPr b="1"/>
-              <a:t>Transition:</a:t>
-            </a:r>
-            <a:r>
-              <a:t> “The practical question is whether the model provides a useful ranking for broad-area screening.”</a:t>
-            </a:r>
-          </a:p>
-          <a:p xmlns:a="http://schemas.openxmlformats.org/drawingml/2006/main">
-            <a:endParaRPr b="1"/>
-          </a:p>
-          <a:p xmlns:a="http://schemas.openxmlformats.org/drawingml/2006/main">
-            <a:r>
-              <a:rPr b="1"/>
-              <a:t>[Sources]</a:t>
-            </a:r>
-            <a:br/>
-            <a:r>
-              <a:t>reports/validation/model_final_decision.md</a:t>
-            </a:r>
-            <a:br/>
-            <a:r>
-              <a:t>reports/validation/final_temporal_test_2022_2024.md</a:t>
-            </a:r>
-            <a:br/>
-            <a:r>
-              <a:t>reports/figures/model_final_test_metric_comparison.png</a:t>
+              <a:t>reports/validation/model_final_decision.md; reports/validation/final_temporal_test_2022_2024.md; reports/figures/model_final_test_metric_comparison.png</a:t>
             </a:r>
           </a:p>
         </p:txBody>
@@ -1731,7 +1651,7 @@
   </p:cSld>
   <p:clrMap bg1="lt1" tx1="dk1" bg2="lt2" tx2="dk2" accent1="accent1" accent2="accent2" accent3="accent3" accent4="accent4" accent5="accent5" accent6="accent6" hlink="hlink" folHlink="folHlink"/>
   <p:sldLayoutIdLst>
-    <p:sldLayoutId xmlns:r="http://schemas.openxmlformats.org/officeDocument/2006/relationships" id="2147483649" r:id="R9368d52527814e51"/>
+    <p:sldLayoutId xmlns:r="http://schemas.openxmlformats.org/officeDocument/2006/relationships" id="2147483649" r:id="R2e44dcc9c4524121"/>
   </p:sldLayoutIdLst>
   <p:hf sldNum="0" hdr="0" ftr="0" dt="0"/>
   <p:txStyles>
@@ -3682,7 +3602,7 @@
                   <a:srgbClr val="1A2638"/>
                 </a:solidFill>
               </a:rPr>
-              <a:t>2000–2025 coverage</a:t>
+              <a:t>ICNF source coverage: 2000–2025</a:t>
             </a:r>
             <a:endParaRPr sz="800"/>
           </a:p>
@@ -5593,7 +5513,7 @@
                   <a:srgbClr val="1A2638"/>
                 </a:solidFill>
               </a:rPr>
-              <a:t>Training T=2010–2019; observed outcomes 2011–2020.</a:t>
+              <a:t>Training: T=2010–2019 → outcomes 2011–2020.</a:t>
             </a:r>
             <a:endParaRPr sz="850"/>
           </a:p>
@@ -5957,7 +5877,7 @@
                   <a:srgbClr val="2A9D61"/>
                 </a:solidFill>
               </a:rPr>
-              <a:t>Use later years in sequence</a:t>
+              <a:t>Validation and final evaluation</a:t>
             </a:r>
             <a:endParaRPr sz="800"/>
           </a:p>
@@ -6000,7 +5920,7 @@
                   <a:srgbClr val="1A2638"/>
                 </a:solidFill>
               </a:rPr>
-              <a:t>Validation T=2020–2021 selects the model; final evaluation T=2022–2024 checks it once.</a:t>
+              <a:t>Validation: T=2020–2021 → outcomes 2021–2022.</a:t>
             </a:r>
             <a:endParaRPr sz="850"/>
           </a:p>
@@ -6076,7 +5996,7 @@
                   <a:srgbClr val="1A2638"/>
                 </a:solidFill>
               </a:rPr>
-              <a:t>Freeze before final evaluation</a:t>
+              <a:t>Final: T=2022–2024 → outcomes 2023–2025</a:t>
             </a:r>
             <a:endParaRPr sz="800"/>
           </a:p>
@@ -6119,7 +6039,7 @@
                   <a:srgbClr val="2A9D61"/>
                 </a:solidFill>
               </a:rPr>
-              <a:t>Outcomes 2021–2022, then 2023–2025</a:t>
+              <a:t>Select on validation; evaluate final once</a:t>
             </a:r>
             <a:endParaRPr sz="750"/>
           </a:p>
@@ -6238,7 +6158,7 @@
                   <a:srgbClr val="E8A020"/>
                 </a:solidFill>
               </a:rPr>
-              <a:t>REFIT + ESTIMATE 2026 | Refit on labelled T=2010–2024; apply T=2025 predictors. 2026 outcome pending.</a:t>
+              <a:t>REFIT + 2026 ESTIMATE | T=2010–2024 → outcomes 2011–2025; T=2025 inputs → 2026 estimate (outcome pending).</a:t>
             </a:r>
             <a:endParaRPr sz="850"/>
           </a:p>
@@ -6667,7 +6587,7 @@
           <p:nvPr/>
         </p:nvPicPr>
         <p:blipFill>
-          <a:blip xmlns:r="http://schemas.openxmlformats.org/officeDocument/2006/relationships" xmlns:a="http://schemas.openxmlformats.org/drawingml/2006/main" r:embed="R260cfa5ea9ca4002"/>
+          <a:blip xmlns:r="http://schemas.openxmlformats.org/officeDocument/2006/relationships" xmlns:a="http://schemas.openxmlformats.org/drawingml/2006/main" r:embed="R267747eb6fa64a2b"/>
           <a:stretch xmlns:a="http://schemas.openxmlformats.org/drawingml/2006/main">
             <a:fillRect l="0" t="0" r="0" b="0"/>
           </a:stretch>
@@ -10142,7 +10062,7 @@
           <a:p xmlns:a="http://schemas.openxmlformats.org/drawingml/2006/main">
             <a:r>
               <a:rPr sz="800"/>
-              <a:t>Final test: predictor years T=2022–2024; outcomes T+1=2023–2025</a:t>
+              <a:t>Final temporal evaluation: T=2022–2024 → observed outcomes 2023–2025</a:t>
             </a:r>
           </a:p>
         </p:txBody>
@@ -10915,7 +10835,7 @@
                   <a:srgbClr val="E8A020"/>
                 </a:solidFill>
               </a:rPr>
-              <a:t>No final-test result is used to claim a property-level forecast.</a:t>
+              <a:t>No final-evaluation result is used to claim a property-level forecast.</a:t>
             </a:r>
             <a:endParaRPr sz="750"/>
           </a:p>

</xml_diff>

<commit_message>
Notes fixes and consolidation.
</commit_message>
<xml_diff>
--- a/reports/presentation/wildfire_exposure_screening_capstone_final.pptx
+++ b/reports/presentation/wildfire_exposure_screening_capstone_final.pptx
@@ -498,10 +498,7 @@
               <a:rPr lang="en-US" dirty="0"/>
               <a:t>Every analytical record represents the same unit: one mainland Portugal 1 km cell in one predictor year.</a:t>
             </a:r>
-            <a:r>
-              <a:rPr b="0" dirty="0"/>
-              <a:t>.</a:t>
-            </a:r>
+            <a:endParaRPr b="0" dirty="0"/>
           </a:p>
           <a:p>
             <a:endParaRPr dirty="0"/>
@@ -585,7 +582,7 @@
           <a:p>
             <a:r>
               <a:rPr lang="en-US" dirty="0"/>
-              <a:t>Next, I will show the exact training, validation, final-evaluation, refit, and current-estimate periods.</a:t>
+              <a:t>Next, I will show how these records are used to train, select and evaluate the model before producing the 2026 estimate.</a:t>
             </a:r>
           </a:p>
           <a:p>
@@ -762,7 +759,7 @@
           <a:p>
             <a:r>
               <a:rPr lang="en-US" dirty="0"/>
-              <a:t>The next slides compare the observed historical evidence, the official ICNF reference, and the separate model estimate for 2026.</a:t>
+              <a:t>The next slide compares the observed historical evidence, the official ICNF reference, and the separate model estimate for 2026.</a:t>
             </a:r>
           </a:p>
           <a:p>
@@ -1158,21 +1155,13 @@
           <a:p>
             <a:r>
               <a:rPr lang="en-US" dirty="0"/>
-              <a:t>The next slide compares the nine-feature model with a separate recurrence-only benchmark used for model </a:t>
-            </a:r>
-            <a:r>
-              <a:rPr lang="en-US"/>
-              <a:t>evaluation.</a:t>
-            </a:r>
-          </a:p>
-          <a:p>
-            <a:r>
-              <a:rPr lang="en-US"/>
-              <a:t>That </a:t>
-            </a:r>
+              <a:t>The next slide compares the nine-feature model with a separate recurrence-only benchmark used for model evaluation.</a:t>
+            </a:r>
+          </a:p>
+          <a:p>
             <a:r>
               <a:rPr lang="en-US" dirty="0"/>
-              <a:t>benchmark uses a rolling ten-year fire-history feature and is not the fixed 2016–2025 map shown here.</a:t>
+              <a:t>That benchmark uses a rolling ten-year fire-history feature and is not the fixed 2016–2025 map shown here.</a:t>
             </a:r>
           </a:p>
           <a:p>
@@ -1180,20 +1169,21 @@
           </a:p>
           <a:p>
             <a:r>
-              <a:rPr dirty="0"/>
+              <a:rPr lang="en-US" dirty="0"/>
               <a:t>[Sources]</a:t>
             </a:r>
             <a:br>
-              <a:rPr dirty="0"/>
+              <a:rPr lang="en-US" dirty="0"/>
             </a:br>
             <a:r>
-              <a:rPr dirty="0" err="1"/>
+              <a:rPr lang="en-US" dirty="0" err="1"/>
               <a:t>qgis</a:t>
             </a:r>
             <a:r>
-              <a:rPr dirty="0"/>
+              <a:rPr lang="en-US" dirty="0"/>
               <a:t>/README.md; docs/data_dictionary.md; reports/figures/historical_exposure_by_icnf_structural_hazard_crosstab.png</a:t>
             </a:r>
+            <a:endParaRPr dirty="0"/>
           </a:p>
         </p:txBody>
       </p:sp>
@@ -1282,7 +1272,7 @@
             <a:endParaRPr lang="en-US" b="1" dirty="0"/>
           </a:p>
           <a:p>
-            <a:endParaRPr b="1" dirty="0"/>
+            <a:endParaRPr lang="en-US" b="1" dirty="0"/>
           </a:p>
           <a:p>
             <a:r>
@@ -1293,96 +1283,98 @@
           <a:p>
             <a:r>
               <a:rPr lang="en-US" dirty="0"/>
-              <a:t>This slide compares the nine-feature model with a deliberately simple recurrence-only reference.</a:t>
-            </a:r>
+              <a:t>This slide compares the nine-feature model with a deliberately simple recurrence-only reference using the final temporal evaluation: predictor years 2022-2024 and their observed outcomes from 2023-2025.</a:t>
+            </a:r>
+          </a:p>
+          <a:p>
+            <a:endParaRPr lang="en-US" dirty="0"/>
           </a:p>
           <a:p>
             <a:r>
               <a:rPr lang="en-US" dirty="0"/>
-              <a:t>The reference is important because it establishes the minimum performance that a more complex model should beat. It also tests whether land cover, terrain, and climate add useful information beyond previous fire history.</a:t>
-            </a:r>
-          </a:p>
-          <a:p>
+              <a:t>The recurrence-only reference establishes the minimum performance that a more complex model should beat. It uses one predictor: the number of years with burned-area evidence during the previous ten years in the 2 km context.</a:t>
+            </a:r>
+          </a:p>
+          <a:p>
+            <a:r>
+              <a:rPr lang="en-US" dirty="0"/>
+              <a:t>The nine-feature model tests whether land cover, terrain and climate add useful information beyond this fire history.</a:t>
+            </a:r>
+          </a:p>
+          <a:p>
+            <a:endParaRPr lang="en-US" dirty="0"/>
+          </a:p>
+          <a:p>
+            <a:r>
+              <a:rPr lang="en-US" dirty="0"/>
+              <a:t>Because most cell-year outcomes are zero, the nine-feature model uses two gradient-boosting components. One estimates whether the following-year burned share is non-zero.</a:t>
+            </a:r>
+          </a:p>
+          <a:p>
+            <a:r>
+              <a:rPr lang="en-US" dirty="0"/>
+              <a:t>The other estimates its size for positive outcomes. Their results are combined into one continuous burned-share estimate.</a:t>
+            </a:r>
+          </a:p>
+          <a:p>
+            <a:endParaRPr lang="en-US" dirty="0"/>
+          </a:p>
+          <a:p>
+            <a:r>
+              <a:rPr lang="en-US" dirty="0"/>
+              <a:t>MAE decreased from 0.0292 to 0.0209, approximately a 28% reduction in average absolute error.</a:t>
+            </a:r>
+          </a:p>
+          <a:p>
+            <a:r>
+              <a:rPr lang="en-US" dirty="0"/>
+              <a:t>RMSE was almost unchanged and slightly higher, moving from 0.1106 to 0.1110. This means that the model improved typical estimates but did not improve errors associated with the largest outcomes.</a:t>
+            </a:r>
+          </a:p>
+          <a:p>
+            <a:endParaRPr lang="en-US" dirty="0"/>
+          </a:p>
+          <a:p>
+            <a:r>
+              <a:rPr lang="en-US" dirty="0"/>
+              <a:t>Capture@20% increased from 40.2% to 57.2%. For this diagnostic, all final-evaluation cell-year records are ranked by their estimated burned share. </a:t>
+            </a:r>
+          </a:p>
+          <a:p>
+            <a:r>
+              <a:rPr lang="en-US" dirty="0"/>
+              <a:t>The metric measures how much of the total observed burned share occurred within the highest-ranked 20% of those records.</a:t>
+            </a:r>
+          </a:p>
+          <a:p>
+            <a:r>
+              <a:rPr lang="en-US" dirty="0"/>
+              <a:t>This result supports the model only partially. It improves average error and broad-area ranking, but large fire outcomes remain difficult.</a:t>
+            </a:r>
+          </a:p>
+          <a:p>
+            <a:r>
+              <a:rPr lang="en-US" dirty="0"/>
+              <a:t>Capture@20% is not the percentage of Portugal that burned, a buyer threshold, or a property-level forecast.</a:t>
+            </a:r>
+          </a:p>
+          <a:p>
+            <a:endParaRPr lang="en-US" dirty="0"/>
+          </a:p>
+          <a:p>
+            <a:r>
+              <a:rPr lang="en-US" b="1" dirty="0"/>
+              <a:t>Transition:</a:t>
+            </a:r>
             <a:br>
               <a:rPr lang="en-US" dirty="0"/>
             </a:br>
             <a:r>
               <a:rPr lang="en-US" dirty="0"/>
-              <a:t>The reference uses one input: how many of the previous ten years had burned-area evidence within the 2 km context. The nine-feature model combines this fire-history information with land cover, terrain, and climate.</a:t>
-            </a:r>
-            <a:br>
-              <a:rPr lang="en-US" dirty="0"/>
-            </a:br>
-            <a:br>
-              <a:rPr lang="en-US" dirty="0"/>
-            </a:br>
-            <a:r>
-              <a:rPr lang="en-US" dirty="0"/>
-              <a:t>The target contains many zero values, so the nine-feature model uses two gradient-boosting components. One estimates whether the next-year outcome is non-zero, and the other estimates the burned share for positive outcomes. These are combined into one continuous burned-share estimate.</a:t>
-            </a:r>
-            <a:br>
-              <a:rPr lang="en-US" dirty="0"/>
-            </a:br>
-            <a:br>
-              <a:rPr lang="en-US" dirty="0"/>
-            </a:br>
-            <a:r>
-              <a:rPr lang="en-US" b="1" dirty="0"/>
-              <a:t>In the final temporal evaluation, MAE decreased from 0.0292 to 0.0209. This is approximately a 28% reduction in average absolute error.</a:t>
-            </a:r>
-            <a:br>
-              <a:rPr lang="en-US" dirty="0"/>
-            </a:br>
-            <a:br>
-              <a:rPr lang="en-US" dirty="0"/>
-            </a:br>
-            <a:r>
-              <a:rPr lang="en-US" dirty="0"/>
-              <a:t>RMSE remained almost unchanged and was slightly higher. This tells us that the model improved typical estimates but did not solve the problem of rare, large-fire outcomes.</a:t>
-            </a:r>
-            <a:br>
-              <a:rPr lang="en-US" dirty="0"/>
-            </a:br>
-            <a:br>
-              <a:rPr lang="en-US" dirty="0"/>
-            </a:br>
-            <a:r>
-              <a:rPr lang="en-US" dirty="0"/>
-              <a:t>Capture@20% also improved from 40.2% to 57.2%. This means that the highest-ranked one-fifth of cell-year records contained a larger share of the burned area that was later observed.</a:t>
-            </a:r>
-            <a:br>
-              <a:rPr lang="en-US" dirty="0"/>
-            </a:br>
-            <a:endParaRPr dirty="0"/>
-          </a:p>
-          <a:p>
-            <a:r>
-              <a:rPr dirty="0"/>
-              <a:t>Transition: </a:t>
-            </a:r>
-            <a:r>
-              <a:rPr lang="en-US" dirty="0"/>
-              <a:t>The next slide explains how the 2026 comparative estimate can be used to narrow broad areas for further research.</a:t>
-            </a:r>
-            <a:br>
-              <a:rPr lang="en-US" dirty="0"/>
-            </a:br>
-            <a:br>
-              <a:rPr lang="en-US" dirty="0"/>
-            </a:br>
-            <a:r>
-              <a:rPr lang="en-US" b="1" dirty="0"/>
-              <a:t>The result therefore provides partial support for the model.</a:t>
-            </a:r>
-          </a:p>
-          <a:p>
-            <a:r>
-              <a:rPr lang="en-US" b="1" dirty="0"/>
-              <a:t>It improves average error and broad-area ranking, but it is not a precise local forecast and remains uncertain during extreme fire years.</a:t>
-            </a:r>
-            <a:br>
-              <a:rPr lang="en-US" dirty="0"/>
-            </a:br>
+              <a:t>The next slide shows how the 2026 comparative estimate can be used to narrow broad areas for further research.</a:t>
+            </a:r>
+          </a:p>
+          <a:p>
             <a:endParaRPr dirty="0"/>
           </a:p>
           <a:p>
@@ -1908,7 +1900,15 @@
           <a:p>
             <a:r>
               <a:rPr lang="en-US" dirty="0"/>
-              <a:t>However, it did not improve errors for large and extreme fire outcomes.</a:t>
+              <a:t>However, </a:t>
+            </a:r>
+            <a:r>
+              <a:rPr lang="en-US" b="1" dirty="0"/>
+              <a:t>RMSE</a:t>
+            </a:r>
+            <a:r>
+              <a:rPr lang="en-US" dirty="0"/>
+              <a:t> did not improve, showing that large and extreme fire outcomes remain difficult.</a:t>
             </a:r>
           </a:p>
           <a:p>
@@ -1935,7 +1935,7 @@
           <a:p>
             <a:r>
               <a:rPr lang="en-US" dirty="0"/>
-              <a:t>After the required 2026 predictor data are validated, the same selected model can be updated with the new completed evidence and used to produce the next annual estimate.</a:t>
+              <a:t>After the required 2026 predictor data and observed outcome are validated, the same selected model can be rebuilt with the new completed evidence and used to produce the 2027 comparative estimate.</a:t>
             </a:r>
           </a:p>
           <a:p>
@@ -7341,14 +7341,22 @@
               <a:buNone/>
             </a:pPr>
             <a:r>
-              <a:rPr sz="850">
+              <a:rPr lang="en-US" sz="850" dirty="0">
                 <a:solidFill>
                   <a:srgbClr val="1A2638"/>
                 </a:solidFill>
               </a:rPr>
-              <a:t>Counts 2016–2025 burned years in the 2 km context around each 1 km cell.</a:t>
-            </a:r>
-            <a:endParaRPr sz="850"/>
+              <a:t>Counts distinct years with burned-area evidence from 2016-2025 in the 2 km context around each 1 km cell</a:t>
+            </a:r>
+            <a:r>
+              <a:rPr sz="850" dirty="0">
+                <a:solidFill>
+                  <a:srgbClr val="1A2638"/>
+                </a:solidFill>
+              </a:rPr>
+              <a:t>.</a:t>
+            </a:r>
+            <a:endParaRPr sz="850" dirty="0"/>
           </a:p>
         </p:txBody>
       </p:sp>
@@ -10868,14 +10876,30 @@
               <a:buNone/>
             </a:pPr>
             <a:r>
-              <a:rPr sz="800">
+              <a:rPr sz="800" dirty="0">
                 <a:solidFill>
                   <a:srgbClr val="1A2638"/>
                 </a:solidFill>
               </a:rPr>
-              <a:t>Capture@20% is the share of observed burned share found among the 20% highest-scored cells.</a:t>
-            </a:r>
-            <a:endParaRPr sz="800"/>
+              <a:t>Capture@20% is the share of observed burned share found among the 20% highest-scored </a:t>
+            </a:r>
+            <a:r>
+              <a:rPr lang="en-US" sz="800" dirty="0">
+                <a:solidFill>
+                  <a:srgbClr val="1A2638"/>
+                </a:solidFill>
+              </a:rPr>
+              <a:t>records</a:t>
+            </a:r>
+            <a:r>
+              <a:rPr sz="800" dirty="0">
+                <a:solidFill>
+                  <a:srgbClr val="1A2638"/>
+                </a:solidFill>
+              </a:rPr>
+              <a:t>.</a:t>
+            </a:r>
+            <a:endParaRPr sz="800" dirty="0"/>
           </a:p>
         </p:txBody>
       </p:sp>

</xml_diff>

<commit_message>
PPTX wording fix and map layers.
</commit_message>
<xml_diff>
--- a/reports/presentation/wildfire_exposure_screening_capstone_final.pptx
+++ b/reports/presentation/wildfire_exposure_screening_capstone_final.pptx
@@ -1351,15 +1351,23 @@
             </a:r>
             <a:r>
               <a:rPr lang="en-US" dirty="0"/>
-              <a:t>it is a technical evaluation measure</a:t>
-            </a:r>
-            <a:r>
-              <a:rPr lang="ru-RU" dirty="0"/>
-              <a:t>ю</a:t>
+              <a:t>it is a technical </a:t>
+            </a:r>
+            <a:r>
+              <a:rPr lang="en-US"/>
+              <a:t>evaluation measure</a:t>
             </a:r>
             <a:r>
               <a:rPr lang="en-US" dirty="0"/>
-              <a:t> However, this is not a fire probability or a buyer threshold.</a:t>
+              <a:t>.</a:t>
+            </a:r>
+            <a:r>
+              <a:rPr lang="en-US"/>
+              <a:t> </a:t>
+            </a:r>
+            <a:r>
+              <a:rPr lang="en-US" dirty="0"/>
+              <a:t>However, this is not a fire probability or a buyer threshold.</a:t>
             </a:r>
           </a:p>
           <a:p>

</xml_diff>